<commit_message>
changes in the ppt
</commit_message>
<xml_diff>
--- a/The 15-Minute City in Practice.pptx
+++ b/The 15-Minute City in Practice.pptx
@@ -127,6 +127,88 @@
   <p188:author id="{DE3E4DB8-4E12-F18C-200B-095F2E882368}" name="Kern  Lucie" initials="KL" userId="S::kernlu@ethz.ch::73957d06-79f2-4001-a218-8bdcb8f96aaa" providerId="AD"/>
   <p188:author id="{C91F3CF6-149F-06F0-0291-18BB8A7035EF}" name="Noémie Simon" initials="NS" userId="bcf751ccc0c63cc4" providerId="Windows Live"/>
 </p188:authorLst>
+</file>
+
+<file path=ppt/revisionInfo.xml><?xml version="1.0" encoding="utf-8"?>
+<p1510:revInfo xmlns:a="http://schemas.openxmlformats.org/drawingml/2006/main" xmlns:r="http://schemas.openxmlformats.org/officeDocument/2006/relationships" xmlns:p1510="http://schemas.microsoft.com/office/powerpoint/2015/10/main">
+  <p1510:revLst>
+    <p1510:client id="{5E255A67-A6A9-4968-8E92-A1C96BA15CA7}" v="2" dt="2026-06-02T17:30:52.206"/>
+  </p1510:revLst>
+</p1510:revInfo>
+</file>
+
+<file path=ppt/changesInfos/changesInfo1.xml><?xml version="1.0" encoding="utf-8"?>
+<pc:chgInfo xmlns:a="http://schemas.openxmlformats.org/drawingml/2006/main" xmlns:r="http://schemas.openxmlformats.org/officeDocument/2006/relationships" xmlns:ac="http://schemas.microsoft.com/office/drawing/2013/main/command" xmlns:pc="http://schemas.microsoft.com/office/powerpoint/2013/main/command">
+  <pc:docChgLst>
+    <pc:chgData name="Noémie Simon" userId="bcf751ccc0c63cc4" providerId="LiveId" clId="{D8646A5F-B639-4467-90AE-53976C914447}"/>
+    <pc:docChg chg="modSld">
+      <pc:chgData name="Noémie Simon" userId="bcf751ccc0c63cc4" providerId="LiveId" clId="{D8646A5F-B639-4467-90AE-53976C914447}" dt="2026-06-02T17:40:20.969" v="104" actId="729"/>
+      <pc:docMkLst>
+        <pc:docMk/>
+      </pc:docMkLst>
+      <pc:sldChg chg="modSp mod">
+        <pc:chgData name="Noémie Simon" userId="bcf751ccc0c63cc4" providerId="LiveId" clId="{D8646A5F-B639-4467-90AE-53976C914447}" dt="2026-06-02T17:32:45.254" v="101" actId="20577"/>
+        <pc:sldMkLst>
+          <pc:docMk/>
+          <pc:sldMk cId="3359249337" sldId="256"/>
+        </pc:sldMkLst>
+        <pc:spChg chg="mod">
+          <ac:chgData name="Noémie Simon" userId="bcf751ccc0c63cc4" providerId="LiveId" clId="{D8646A5F-B639-4467-90AE-53976C914447}" dt="2026-06-02T17:32:45.254" v="101" actId="20577"/>
+          <ac:spMkLst>
+            <pc:docMk/>
+            <pc:sldMk cId="3359249337" sldId="256"/>
+            <ac:spMk id="2" creationId="{55269C2F-6BFD-EFC2-398D-9FE490AB97CC}"/>
+          </ac:spMkLst>
+        </pc:spChg>
+      </pc:sldChg>
+      <pc:sldChg chg="mod modShow">
+        <pc:chgData name="Noémie Simon" userId="bcf751ccc0c63cc4" providerId="LiveId" clId="{D8646A5F-B639-4467-90AE-53976C914447}" dt="2026-06-02T17:40:20.969" v="104" actId="729"/>
+        <pc:sldMkLst>
+          <pc:docMk/>
+          <pc:sldMk cId="3526247385" sldId="257"/>
+        </pc:sldMkLst>
+      </pc:sldChg>
+      <pc:sldChg chg="mod modShow">
+        <pc:chgData name="Noémie Simon" userId="bcf751ccc0c63cc4" providerId="LiveId" clId="{D8646A5F-B639-4467-90AE-53976C914447}" dt="2026-06-02T17:40:15.898" v="103" actId="729"/>
+        <pc:sldMkLst>
+          <pc:docMk/>
+          <pc:sldMk cId="2296812319" sldId="258"/>
+        </pc:sldMkLst>
+      </pc:sldChg>
+      <pc:sldChg chg="modSp mod">
+        <pc:chgData name="Noémie Simon" userId="bcf751ccc0c63cc4" providerId="LiveId" clId="{D8646A5F-B639-4467-90AE-53976C914447}" dt="2026-06-02T17:40:05.580" v="102" actId="1076"/>
+        <pc:sldMkLst>
+          <pc:docMk/>
+          <pc:sldMk cId="131123478" sldId="266"/>
+        </pc:sldMkLst>
+        <pc:spChg chg="mod">
+          <ac:chgData name="Noémie Simon" userId="bcf751ccc0c63cc4" providerId="LiveId" clId="{D8646A5F-B639-4467-90AE-53976C914447}" dt="2026-06-02T17:30:15.351" v="3" actId="20577"/>
+          <ac:spMkLst>
+            <pc:docMk/>
+            <pc:sldMk cId="131123478" sldId="266"/>
+            <ac:spMk id="11" creationId="{1721DAEC-0A82-6021-A4E5-89B28C221F2F}"/>
+          </ac:spMkLst>
+        </pc:spChg>
+        <pc:spChg chg="mod">
+          <ac:chgData name="Noémie Simon" userId="bcf751ccc0c63cc4" providerId="LiveId" clId="{D8646A5F-B639-4467-90AE-53976C914447}" dt="2026-06-02T17:30:59.299" v="64" actId="20577"/>
+          <ac:spMkLst>
+            <pc:docMk/>
+            <pc:sldMk cId="131123478" sldId="266"/>
+            <ac:spMk id="18" creationId="{214E7150-6D34-BA9C-1FC7-E2FD88FAB998}"/>
+          </ac:spMkLst>
+        </pc:spChg>
+        <pc:spChg chg="mod">
+          <ac:chgData name="Noémie Simon" userId="bcf751ccc0c63cc4" providerId="LiveId" clId="{D8646A5F-B639-4467-90AE-53976C914447}" dt="2026-06-02T17:40:05.580" v="102" actId="1076"/>
+          <ac:spMkLst>
+            <pc:docMk/>
+            <pc:sldMk cId="131123478" sldId="266"/>
+            <ac:spMk id="22" creationId="{4C50DE4D-9766-DAB7-AB84-B23FAE884ECD}"/>
+          </ac:spMkLst>
+        </pc:spChg>
+      </pc:sldChg>
+    </pc:docChg>
+  </pc:docChgLst>
+</pc:chgInfo>
 </file>
 
 <file path=ppt/comments/modernComment_100_C83A13B9.xml><?xml version="1.0" encoding="utf-8"?>
@@ -1629,10 +1711,10 @@
   <dgm:cxnLst>
     <dgm:cxn modelId="{1ECB5511-AEE1-4BBA-B91B-D516215FE7D6}" srcId="{72C74514-7E59-43DD-81F2-44D5759C1824}" destId="{A40C8A38-7AAB-4A1C-B39A-DBED66B60A11}" srcOrd="5" destOrd="0" parTransId="{E5A7B580-C647-42C1-94EA-2AD96FD66632}" sibTransId="{30FCC906-E4C0-41AD-A5E6-88449F9BC921}"/>
     <dgm:cxn modelId="{B039D11B-C065-4DB7-9C3F-9C1F1452DDD1}" srcId="{72C74514-7E59-43DD-81F2-44D5759C1824}" destId="{12C6A796-E05E-4109-83A5-CA6732F07DCC}" srcOrd="0" destOrd="0" parTransId="{A758E241-A4DE-442B-90CA-0C9C5F9396E7}" sibTransId="{13D06279-7FFC-4E91-975B-C5F631451C36}"/>
+    <dgm:cxn modelId="{F3787362-5CE9-48E2-99AE-A2FA95701E60}" srcId="{72C74514-7E59-43DD-81F2-44D5759C1824}" destId="{7157FA5E-C5A4-4039-9621-57EE8A1E448F}" srcOrd="2" destOrd="0" parTransId="{874C9894-94B6-42CC-B8D0-400E1D54079E}" sibTransId="{1E46E158-B5CD-4F93-9646-8137B2D6040A}"/>
     <dgm:cxn modelId="{E5A2F242-6C0F-452E-9348-36AAA3844FB6}" type="presOf" srcId="{59572103-8EAB-4A50-AB21-192D24EA143A}" destId="{97E83598-7549-4D53-BBE1-0E6AEBC831C5}" srcOrd="0" destOrd="0" presId="urn:microsoft.com/office/officeart/2005/8/layout/vList2"/>
+    <dgm:cxn modelId="{CE80F663-3A3B-4D24-B6E6-0C77D0FB47EC}" type="presOf" srcId="{A40C8A38-7AAB-4A1C-B39A-DBED66B60A11}" destId="{4600E2F4-4816-42E1-84E1-9746CD5EE6E1}" srcOrd="0" destOrd="0" presId="urn:microsoft.com/office/officeart/2005/8/layout/vList2"/>
     <dgm:cxn modelId="{95C9FA46-ECF1-4D14-8548-452CDC7D2175}" srcId="{72C74514-7E59-43DD-81F2-44D5759C1824}" destId="{41B0F318-681F-480C-ACBE-4C24B27636D0}" srcOrd="1" destOrd="0" parTransId="{0D659330-D588-4B5E-A5C6-35292AF1DC95}" sibTransId="{207A3D5B-4122-4CE8-B141-67DFCED8E158}"/>
-    <dgm:cxn modelId="{F3787362-5CE9-48E2-99AE-A2FA95701E60}" srcId="{72C74514-7E59-43DD-81F2-44D5759C1824}" destId="{7157FA5E-C5A4-4039-9621-57EE8A1E448F}" srcOrd="2" destOrd="0" parTransId="{874C9894-94B6-42CC-B8D0-400E1D54079E}" sibTransId="{1E46E158-B5CD-4F93-9646-8137B2D6040A}"/>
-    <dgm:cxn modelId="{CE80F663-3A3B-4D24-B6E6-0C77D0FB47EC}" type="presOf" srcId="{A40C8A38-7AAB-4A1C-B39A-DBED66B60A11}" destId="{4600E2F4-4816-42E1-84E1-9746CD5EE6E1}" srcOrd="0" destOrd="0" presId="urn:microsoft.com/office/officeart/2005/8/layout/vList2"/>
     <dgm:cxn modelId="{E714E36B-BA29-4B1C-A5A6-DC818E048543}" type="presOf" srcId="{72C74514-7E59-43DD-81F2-44D5759C1824}" destId="{2DC07872-A69E-402A-96DD-C56028D57122}" srcOrd="0" destOrd="0" presId="urn:microsoft.com/office/officeart/2005/8/layout/vList2"/>
     <dgm:cxn modelId="{676CAB7E-46F8-4503-A039-13561D369C78}" type="presOf" srcId="{12C6A796-E05E-4109-83A5-CA6732F07DCC}" destId="{246B3F6D-7E01-4EA4-AD38-6D0AD826CB2B}" srcOrd="0" destOrd="0" presId="urn:microsoft.com/office/officeart/2005/8/layout/vList2"/>
     <dgm:cxn modelId="{98AFD998-7383-4817-8CB5-6E3ABE5884B8}" type="presOf" srcId="{7157FA5E-C5A4-4039-9621-57EE8A1E448F}" destId="{0226B3E9-17B7-42EC-B955-CDCAEF4B2B67}" srcOrd="0" destOrd="0" presId="urn:microsoft.com/office/officeart/2005/8/layout/vList2"/>
@@ -1681,8 +1763,8 @@
       </dsp:nvSpPr>
       <dsp:spPr>
         <a:xfrm>
-          <a:off x="0" y="5923"/>
-          <a:ext cx="10515600" cy="608851"/>
+          <a:off x="0" y="3160"/>
+          <a:ext cx="10515600" cy="612150"/>
         </a:xfrm>
         <a:prstGeom prst="roundRect">
           <a:avLst/>
@@ -1786,8 +1868,8 @@
         </a:p>
       </dsp:txBody>
       <dsp:txXfrm>
-        <a:off x="29722" y="35645"/>
-        <a:ext cx="10456156" cy="549407"/>
+        <a:off x="29883" y="33043"/>
+        <a:ext cx="10455834" cy="552384"/>
       </dsp:txXfrm>
     </dsp:sp>
     <dsp:sp modelId="{1492B98B-63EB-43A1-8A5D-476D085DE6CB}">
@@ -1797,8 +1879,8 @@
       </dsp:nvSpPr>
       <dsp:spPr>
         <a:xfrm>
-          <a:off x="0" y="624993"/>
-          <a:ext cx="10515600" cy="608851"/>
+          <a:off x="0" y="623214"/>
+          <a:ext cx="10515600" cy="612150"/>
         </a:xfrm>
         <a:prstGeom prst="roundRect">
           <a:avLst/>
@@ -1898,8 +1980,8 @@
         </a:p>
       </dsp:txBody>
       <dsp:txXfrm>
-        <a:off x="29722" y="654715"/>
-        <a:ext cx="10456156" cy="549407"/>
+        <a:off x="29883" y="653097"/>
+        <a:ext cx="10455834" cy="552384"/>
       </dsp:txXfrm>
     </dsp:sp>
     <dsp:sp modelId="{0226B3E9-17B7-42EC-B955-CDCAEF4B2B67}">
@@ -1909,8 +1991,8 @@
       </dsp:nvSpPr>
       <dsp:spPr>
         <a:xfrm>
-          <a:off x="0" y="1248118"/>
-          <a:ext cx="10515600" cy="608851"/>
+          <a:off x="0" y="1246404"/>
+          <a:ext cx="10515600" cy="612150"/>
         </a:xfrm>
         <a:prstGeom prst="roundRect">
           <a:avLst/>
@@ -2010,8 +2092,8 @@
         </a:p>
       </dsp:txBody>
       <dsp:txXfrm>
-        <a:off x="29722" y="1277840"/>
-        <a:ext cx="10456156" cy="549407"/>
+        <a:off x="29883" y="1276287"/>
+        <a:ext cx="10455834" cy="552384"/>
       </dsp:txXfrm>
     </dsp:sp>
     <dsp:sp modelId="{97E83598-7549-4D53-BBE1-0E6AEBC831C5}">
@@ -2021,8 +2103,8 @@
       </dsp:nvSpPr>
       <dsp:spPr>
         <a:xfrm>
-          <a:off x="0" y="1871243"/>
-          <a:ext cx="10515600" cy="608851"/>
+          <a:off x="0" y="1869593"/>
+          <a:ext cx="10515600" cy="612150"/>
         </a:xfrm>
         <a:prstGeom prst="roundRect">
           <a:avLst/>
@@ -2154,8 +2236,8 @@
         </a:p>
       </dsp:txBody>
       <dsp:txXfrm>
-        <a:off x="29722" y="1900965"/>
-        <a:ext cx="10456156" cy="549407"/>
+        <a:off x="29883" y="1899476"/>
+        <a:ext cx="10455834" cy="552384"/>
       </dsp:txXfrm>
     </dsp:sp>
     <dsp:sp modelId="{ED8365DF-6489-4474-AD72-A519E8BD5BF3}">
@@ -2165,8 +2247,8 @@
       </dsp:nvSpPr>
       <dsp:spPr>
         <a:xfrm>
-          <a:off x="0" y="2494368"/>
-          <a:ext cx="10515600" cy="608851"/>
+          <a:off x="0" y="2492783"/>
+          <a:ext cx="10515600" cy="612150"/>
         </a:xfrm>
         <a:prstGeom prst="roundRect">
           <a:avLst/>
@@ -2274,8 +2356,8 @@
         </a:p>
       </dsp:txBody>
       <dsp:txXfrm>
-        <a:off x="29722" y="2524090"/>
-        <a:ext cx="10456156" cy="549407"/>
+        <a:off x="29883" y="2522666"/>
+        <a:ext cx="10455834" cy="552384"/>
       </dsp:txXfrm>
     </dsp:sp>
     <dsp:sp modelId="{4600E2F4-4816-42E1-84E1-9746CD5EE6E1}">
@@ -2285,8 +2367,8 @@
       </dsp:nvSpPr>
       <dsp:spPr>
         <a:xfrm>
-          <a:off x="0" y="3117492"/>
-          <a:ext cx="10515600" cy="608851"/>
+          <a:off x="0" y="3115972"/>
+          <a:ext cx="10515600" cy="612150"/>
         </a:xfrm>
         <a:prstGeom prst="roundRect">
           <a:avLst/>
@@ -2406,8 +2488,8 @@
         </a:p>
       </dsp:txBody>
       <dsp:txXfrm>
-        <a:off x="29722" y="3147214"/>
-        <a:ext cx="10456156" cy="549407"/>
+        <a:off x="29883" y="3145855"/>
+        <a:ext cx="10455834" cy="552384"/>
       </dsp:txXfrm>
     </dsp:sp>
     <dsp:sp modelId="{3DD9623C-BD4B-4DD5-BA45-58C18A024881}">
@@ -2417,8 +2499,8 @@
       </dsp:nvSpPr>
       <dsp:spPr>
         <a:xfrm>
-          <a:off x="0" y="3740617"/>
-          <a:ext cx="10515600" cy="608851"/>
+          <a:off x="0" y="3739162"/>
+          <a:ext cx="10515600" cy="612150"/>
         </a:xfrm>
         <a:prstGeom prst="roundRect">
           <a:avLst/>
@@ -2510,8 +2592,8 @@
         </a:p>
       </dsp:txBody>
       <dsp:txXfrm>
-        <a:off x="29722" y="3770339"/>
-        <a:ext cx="10456156" cy="549407"/>
+        <a:off x="29883" y="3769045"/>
+        <a:ext cx="10455834" cy="552384"/>
       </dsp:txXfrm>
     </dsp:sp>
   </dsp:spTree>
@@ -3868,7 +3950,7 @@
           <a:p>
             <a:fld id="{6DABDDBB-0918-4A38-BFF3-738DBDB6A6F7}" type="datetimeFigureOut">
               <a:rPr lang="fr-CH" smtClean="0"/>
-              <a:t>01.06.26</a:t>
+              <a:t>02.06.2026</a:t>
             </a:fld>
             <a:endParaRPr lang="fr-CH"/>
           </a:p>
@@ -4068,7 +4150,7 @@
           <a:p>
             <a:fld id="{6DABDDBB-0918-4A38-BFF3-738DBDB6A6F7}" type="datetimeFigureOut">
               <a:rPr lang="fr-CH" smtClean="0"/>
-              <a:t>01.06.26</a:t>
+              <a:t>02.06.2026</a:t>
             </a:fld>
             <a:endParaRPr lang="fr-CH"/>
           </a:p>
@@ -4278,7 +4360,7 @@
           <a:p>
             <a:fld id="{6DABDDBB-0918-4A38-BFF3-738DBDB6A6F7}" type="datetimeFigureOut">
               <a:rPr lang="fr-CH" smtClean="0"/>
-              <a:t>01.06.26</a:t>
+              <a:t>02.06.2026</a:t>
             </a:fld>
             <a:endParaRPr lang="fr-CH"/>
           </a:p>
@@ -4478,7 +4560,7 @@
           <a:p>
             <a:fld id="{6DABDDBB-0918-4A38-BFF3-738DBDB6A6F7}" type="datetimeFigureOut">
               <a:rPr lang="fr-CH" smtClean="0"/>
-              <a:t>01.06.26</a:t>
+              <a:t>02.06.2026</a:t>
             </a:fld>
             <a:endParaRPr lang="fr-CH"/>
           </a:p>
@@ -4754,7 +4836,7 @@
           <a:p>
             <a:fld id="{6DABDDBB-0918-4A38-BFF3-738DBDB6A6F7}" type="datetimeFigureOut">
               <a:rPr lang="fr-CH" smtClean="0"/>
-              <a:t>01.06.26</a:t>
+              <a:t>02.06.2026</a:t>
             </a:fld>
             <a:endParaRPr lang="fr-CH"/>
           </a:p>
@@ -5022,7 +5104,7 @@
           <a:p>
             <a:fld id="{6DABDDBB-0918-4A38-BFF3-738DBDB6A6F7}" type="datetimeFigureOut">
               <a:rPr lang="fr-CH" smtClean="0"/>
-              <a:t>01.06.26</a:t>
+              <a:t>02.06.2026</a:t>
             </a:fld>
             <a:endParaRPr lang="fr-CH"/>
           </a:p>
@@ -5437,7 +5519,7 @@
           <a:p>
             <a:fld id="{6DABDDBB-0918-4A38-BFF3-738DBDB6A6F7}" type="datetimeFigureOut">
               <a:rPr lang="fr-CH" smtClean="0"/>
-              <a:t>01.06.26</a:t>
+              <a:t>02.06.2026</a:t>
             </a:fld>
             <a:endParaRPr lang="fr-CH"/>
           </a:p>
@@ -5579,7 +5661,7 @@
           <a:p>
             <a:fld id="{6DABDDBB-0918-4A38-BFF3-738DBDB6A6F7}" type="datetimeFigureOut">
               <a:rPr lang="fr-CH" smtClean="0"/>
-              <a:t>01.06.26</a:t>
+              <a:t>02.06.2026</a:t>
             </a:fld>
             <a:endParaRPr lang="fr-CH"/>
           </a:p>
@@ -5692,7 +5774,7 @@
           <a:p>
             <a:fld id="{6DABDDBB-0918-4A38-BFF3-738DBDB6A6F7}" type="datetimeFigureOut">
               <a:rPr lang="fr-CH" smtClean="0"/>
-              <a:t>01.06.26</a:t>
+              <a:t>02.06.2026</a:t>
             </a:fld>
             <a:endParaRPr lang="fr-CH"/>
           </a:p>
@@ -6005,7 +6087,7 @@
           <a:p>
             <a:fld id="{6DABDDBB-0918-4A38-BFF3-738DBDB6A6F7}" type="datetimeFigureOut">
               <a:rPr lang="fr-CH" smtClean="0"/>
-              <a:t>01.06.26</a:t>
+              <a:t>02.06.2026</a:t>
             </a:fld>
             <a:endParaRPr lang="fr-CH"/>
           </a:p>
@@ -6294,7 +6376,7 @@
           <a:p>
             <a:fld id="{6DABDDBB-0918-4A38-BFF3-738DBDB6A6F7}" type="datetimeFigureOut">
               <a:rPr lang="fr-CH" smtClean="0"/>
-              <a:t>01.06.26</a:t>
+              <a:t>02.06.2026</a:t>
             </a:fld>
             <a:endParaRPr lang="fr-CH"/>
           </a:p>
@@ -6537,7 +6619,7 @@
           <a:p>
             <a:fld id="{6DABDDBB-0918-4A38-BFF3-738DBDB6A6F7}" type="datetimeFigureOut">
               <a:rPr lang="fr-CH" smtClean="0"/>
-              <a:t>01.06.26</a:t>
+              <a:t>02.06.2026</a:t>
             </a:fld>
             <a:endParaRPr lang="fr-CH"/>
           </a:p>
@@ -7071,7 +7153,7 @@
             </a:r>
             <a:r>
               <a:rPr lang="fr-CH" sz="4000" dirty="0" err="1"/>
-              <a:t>Theoretical</a:t>
+              <a:t>theoretical</a:t>
             </a:r>
             <a:r>
               <a:rPr lang="fr-CH" sz="4000" dirty="0"/>
@@ -7079,35 +7161,19 @@
             </a:r>
             <a:r>
               <a:rPr lang="fr-CH" sz="4000" dirty="0" err="1"/>
-              <a:t>Accessibility</a:t>
+              <a:t>accessibility</a:t>
             </a:r>
             <a:r>
               <a:rPr lang="fr-CH" sz="4000" dirty="0"/>
-              <a:t> and </a:t>
+              <a:t> and real </a:t>
             </a:r>
             <a:r>
               <a:rPr lang="fr-CH" sz="4000" dirty="0" err="1"/>
-              <a:t>Actual</a:t>
+              <a:t>mobility</a:t>
             </a:r>
             <a:r>
               <a:rPr lang="fr-CH" sz="4000" dirty="0"/>
-              <a:t> </a:t>
-            </a:r>
-            <a:r>
-              <a:rPr lang="fr-CH" sz="4000" dirty="0" err="1"/>
-              <a:t>Mobility</a:t>
-            </a:r>
-            <a:r>
-              <a:rPr lang="fr-CH" sz="4000" dirty="0"/>
-              <a:t> </a:t>
-            </a:r>
-            <a:r>
-              <a:rPr lang="fr-CH" sz="4000" dirty="0" err="1"/>
-              <a:t>Behavior</a:t>
-            </a:r>
-            <a:r>
-              <a:rPr lang="fr-CH" sz="4000" dirty="0"/>
-              <a:t> in Zurich</a:t>
+              <a:t> patterns in Zurich</a:t>
             </a:r>
           </a:p>
         </p:txBody>
@@ -8129,7 +8195,7 @@
 </file>
 
 <file path=ppt/slides/slide2.xml><?xml version="1.0" encoding="utf-8"?>
-<p:sld xmlns:a="http://schemas.openxmlformats.org/drawingml/2006/main" xmlns:r="http://schemas.openxmlformats.org/officeDocument/2006/relationships" xmlns:p="http://schemas.openxmlformats.org/presentationml/2006/main">
+<p:sld xmlns:a="http://schemas.openxmlformats.org/drawingml/2006/main" xmlns:r="http://schemas.openxmlformats.org/officeDocument/2006/relationships" xmlns:p="http://schemas.openxmlformats.org/presentationml/2006/main" show="0">
   <p:cSld>
     <p:spTree>
       <p:nvGrpSpPr>
@@ -9692,7 +9758,7 @@
 </file>
 
 <file path=ppt/slides/slide3.xml><?xml version="1.0" encoding="utf-8"?>
-<p:sld xmlns:a="http://schemas.openxmlformats.org/drawingml/2006/main" xmlns:r="http://schemas.openxmlformats.org/officeDocument/2006/relationships" xmlns:p="http://schemas.openxmlformats.org/presentationml/2006/main">
+<p:sld xmlns:a="http://schemas.openxmlformats.org/drawingml/2006/main" xmlns:r="http://schemas.openxmlformats.org/officeDocument/2006/relationships" xmlns:p="http://schemas.openxmlformats.org/presentationml/2006/main" show="0">
   <p:cSld>
     <p:bg>
       <p:bgPr>
@@ -12753,27 +12819,39 @@
             </a:r>
             <a:r>
               <a:rPr lang="fr-CH" sz="2200" dirty="0"/>
-              <a:t>Points of </a:t>
+              <a:t>road </a:t>
+            </a:r>
+            <a:r>
+              <a:rPr lang="fr-CH" sz="2200" dirty="0" err="1"/>
+              <a:t>networkt</a:t>
+            </a:r>
+            <a:r>
+              <a:rPr lang="fr-CH" dirty="0"/>
+              <a:t>, </a:t>
+            </a:r>
+            <a:r>
+              <a:rPr lang="fr-CH" sz="2200" dirty="0"/>
+              <a:t>transport infrastructure for </a:t>
+            </a:r>
+            <a:r>
+              <a:rPr lang="fr-CH" sz="2200" dirty="0" err="1"/>
+              <a:t>urban</a:t>
+            </a:r>
+            <a:r>
+              <a:rPr lang="fr-CH" sz="2200" dirty="0"/>
+              <a:t> </a:t>
+            </a:r>
+            <a:r>
+              <a:rPr lang="fr-CH" sz="2200" dirty="0" err="1"/>
+              <a:t>context</a:t>
+            </a:r>
+            <a:r>
+              <a:rPr lang="fr-CH" sz="2200" dirty="0"/>
+              <a:t> and Point of </a:t>
             </a:r>
             <a:r>
               <a:rPr lang="fr-CH" sz="2200" dirty="0" err="1"/>
               <a:t>Interest</a:t>
-            </a:r>
-            <a:r>
-              <a:rPr lang="fr-CH" sz="2200" dirty="0"/>
-              <a:t> and transport infrastructure for </a:t>
-            </a:r>
-            <a:r>
-              <a:rPr lang="fr-CH" sz="2200" dirty="0" err="1"/>
-              <a:t>urban</a:t>
-            </a:r>
-            <a:r>
-              <a:rPr lang="fr-CH" sz="2200" dirty="0"/>
-              <a:t> </a:t>
-            </a:r>
-            <a:r>
-              <a:rPr lang="fr-CH" sz="2200" dirty="0" err="1"/>
-              <a:t>context</a:t>
             </a:r>
             <a:r>
               <a:rPr lang="fr-CH" sz="2200" dirty="0"/>
@@ -12800,7 +12878,7 @@
         </p:nvSpPr>
         <p:spPr>
           <a:xfrm>
-            <a:off x="5730982" y="1560444"/>
+            <a:off x="4551635" y="1418069"/>
             <a:ext cx="3179554" cy="369332"/>
           </a:xfrm>
           <a:prstGeom prst="rect">
@@ -13193,7 +13271,7 @@
           <a:p>
             <a:r>
               <a:rPr lang="fr-CH" sz="2200" dirty="0" err="1"/>
-              <a:t>understand</a:t>
+              <a:t>Understand</a:t>
             </a:r>
             <a:r>
               <a:rPr lang="fr-CH" sz="2200" dirty="0"/>

</xml_diff>

<commit_message>
too late to code
</commit_message>
<xml_diff>
--- a/The 15-Minute City in Practice.pptx
+++ b/The 15-Minute City in Practice.pptx
@@ -6,16 +6,17 @@
   </p:sldMasterIdLst>
   <p:sldIdLst>
     <p:sldId id="256" r:id="rId2"/>
-    <p:sldId id="258" r:id="rId3"/>
-    <p:sldId id="257" r:id="rId4"/>
-    <p:sldId id="266" r:id="rId5"/>
-    <p:sldId id="259" r:id="rId6"/>
-    <p:sldId id="265" r:id="rId7"/>
-    <p:sldId id="263" r:id="rId8"/>
-    <p:sldId id="261" r:id="rId9"/>
-    <p:sldId id="267" r:id="rId10"/>
-    <p:sldId id="268" r:id="rId11"/>
-    <p:sldId id="262" r:id="rId12"/>
+    <p:sldId id="266" r:id="rId3"/>
+    <p:sldId id="270" r:id="rId4"/>
+    <p:sldId id="263" r:id="rId5"/>
+    <p:sldId id="261" r:id="rId6"/>
+    <p:sldId id="267" r:id="rId7"/>
+    <p:sldId id="268" r:id="rId8"/>
+    <p:sldId id="269" r:id="rId9"/>
+    <p:sldId id="262" r:id="rId10"/>
+    <p:sldId id="258" r:id="rId11"/>
+    <p:sldId id="257" r:id="rId12"/>
+    <p:sldId id="265" r:id="rId13"/>
   </p:sldIdLst>
   <p:sldSz cx="12192000" cy="6858000"/>
   <p:notesSz cx="6858000" cy="9144000"/>
@@ -132,7 +133,7 @@
 <file path=ppt/revisionInfo.xml><?xml version="1.0" encoding="utf-8"?>
 <p1510:revInfo xmlns:a="http://schemas.openxmlformats.org/drawingml/2006/main" xmlns:r="http://schemas.openxmlformats.org/officeDocument/2006/relationships" xmlns:p1510="http://schemas.microsoft.com/office/powerpoint/2015/10/main">
   <p1510:revLst>
-    <p1510:client id="{5E255A67-A6A9-4968-8E92-A1C96BA15CA7}" v="2" dt="2026-06-02T17:30:52.206"/>
+    <p1510:client id="{5E255A67-A6A9-4968-8E92-A1C96BA15CA7}" v="4" dt="2026-06-02T20:47:20.306"/>
   </p1510:revLst>
 </p1510:revInfo>
 </file>
@@ -141,8 +142,8 @@
 <pc:chgInfo xmlns:a="http://schemas.openxmlformats.org/drawingml/2006/main" xmlns:r="http://schemas.openxmlformats.org/officeDocument/2006/relationships" xmlns:ac="http://schemas.microsoft.com/office/drawing/2013/main/command" xmlns:pc="http://schemas.microsoft.com/office/powerpoint/2013/main/command">
   <pc:docChgLst>
     <pc:chgData name="Noémie Simon" userId="bcf751ccc0c63cc4" providerId="LiveId" clId="{D8646A5F-B639-4467-90AE-53976C914447}"/>
-    <pc:docChg chg="modSld">
-      <pc:chgData name="Noémie Simon" userId="bcf751ccc0c63cc4" providerId="LiveId" clId="{D8646A5F-B639-4467-90AE-53976C914447}" dt="2026-06-02T17:40:20.969" v="104" actId="729"/>
+    <pc:docChg chg="custSel addSld delSld modSld sldOrd">
+      <pc:chgData name="Noémie Simon" userId="bcf751ccc0c63cc4" providerId="LiveId" clId="{D8646A5F-B639-4467-90AE-53976C914447}" dt="2026-06-02T20:55:29.016" v="158" actId="27614"/>
       <pc:docMkLst>
         <pc:docMk/>
       </pc:docMkLst>
@@ -161,18 +162,40 @@
           </ac:spMkLst>
         </pc:spChg>
       </pc:sldChg>
-      <pc:sldChg chg="mod modShow">
-        <pc:chgData name="Noémie Simon" userId="bcf751ccc0c63cc4" providerId="LiveId" clId="{D8646A5F-B639-4467-90AE-53976C914447}" dt="2026-06-02T17:40:20.969" v="104" actId="729"/>
+      <pc:sldChg chg="mod ord modShow">
+        <pc:chgData name="Noémie Simon" userId="bcf751ccc0c63cc4" providerId="LiveId" clId="{D8646A5F-B639-4467-90AE-53976C914447}" dt="2026-06-02T20:48:46.207" v="147"/>
         <pc:sldMkLst>
           <pc:docMk/>
           <pc:sldMk cId="3526247385" sldId="257"/>
         </pc:sldMkLst>
       </pc:sldChg>
-      <pc:sldChg chg="mod modShow">
-        <pc:chgData name="Noémie Simon" userId="bcf751ccc0c63cc4" providerId="LiveId" clId="{D8646A5F-B639-4467-90AE-53976C914447}" dt="2026-06-02T17:40:15.898" v="103" actId="729"/>
+      <pc:sldChg chg="mod ord modShow">
+        <pc:chgData name="Noémie Simon" userId="bcf751ccc0c63cc4" providerId="LiveId" clId="{D8646A5F-B639-4467-90AE-53976C914447}" dt="2026-06-02T20:48:39.632" v="145"/>
         <pc:sldMkLst>
           <pc:docMk/>
           <pc:sldMk cId="2296812319" sldId="258"/>
+        </pc:sldMkLst>
+      </pc:sldChg>
+      <pc:sldChg chg="modSp del mod">
+        <pc:chgData name="Noémie Simon" userId="bcf751ccc0c63cc4" providerId="LiveId" clId="{D8646A5F-B639-4467-90AE-53976C914447}" dt="2026-06-02T20:48:20.612" v="143" actId="2696"/>
+        <pc:sldMkLst>
+          <pc:docMk/>
+          <pc:sldMk cId="3809305011" sldId="259"/>
+        </pc:sldMkLst>
+        <pc:spChg chg="mod">
+          <ac:chgData name="Noémie Simon" userId="bcf751ccc0c63cc4" providerId="LiveId" clId="{D8646A5F-B639-4467-90AE-53976C914447}" dt="2026-06-02T20:46:41.495" v="121" actId="21"/>
+          <ac:spMkLst>
+            <pc:docMk/>
+            <pc:sldMk cId="3809305011" sldId="259"/>
+            <ac:spMk id="2" creationId="{3ED5FDDA-FB89-7C42-000C-DFB890DC4FCA}"/>
+          </ac:spMkLst>
+        </pc:spChg>
+      </pc:sldChg>
+      <pc:sldChg chg="mod ord modShow">
+        <pc:chgData name="Noémie Simon" userId="bcf751ccc0c63cc4" providerId="LiveId" clId="{D8646A5F-B639-4467-90AE-53976C914447}" dt="2026-06-02T20:48:51.571" v="149"/>
+        <pc:sldMkLst>
+          <pc:docMk/>
+          <pc:sldMk cId="2129016569" sldId="265"/>
         </pc:sldMkLst>
       </pc:sldChg>
       <pc:sldChg chg="modSp mod">
@@ -203,6 +226,107 @@
             <pc:docMk/>
             <pc:sldMk cId="131123478" sldId="266"/>
             <ac:spMk id="22" creationId="{4C50DE4D-9766-DAB7-AB84-B23FAE884ECD}"/>
+          </ac:spMkLst>
+        </pc:spChg>
+      </pc:sldChg>
+      <pc:sldChg chg="modSp mod">
+        <pc:chgData name="Noémie Simon" userId="bcf751ccc0c63cc4" providerId="LiveId" clId="{D8646A5F-B639-4467-90AE-53976C914447}" dt="2026-06-02T20:54:09.362" v="155" actId="113"/>
+        <pc:sldMkLst>
+          <pc:docMk/>
+          <pc:sldMk cId="3855054443" sldId="268"/>
+        </pc:sldMkLst>
+        <pc:spChg chg="mod">
+          <ac:chgData name="Noémie Simon" userId="bcf751ccc0c63cc4" providerId="LiveId" clId="{D8646A5F-B639-4467-90AE-53976C914447}" dt="2026-06-02T20:54:09.362" v="155" actId="113"/>
+          <ac:spMkLst>
+            <pc:docMk/>
+            <pc:sldMk cId="3855054443" sldId="268"/>
+            <ac:spMk id="2" creationId="{8B6FD0A6-936D-1217-2307-54883D928515}"/>
+          </ac:spMkLst>
+        </pc:spChg>
+      </pc:sldChg>
+      <pc:sldChg chg="addSp delSp modSp new mod ord">
+        <pc:chgData name="Noémie Simon" userId="bcf751ccc0c63cc4" providerId="LiveId" clId="{D8646A5F-B639-4467-90AE-53976C914447}" dt="2026-06-02T20:55:29.016" v="158" actId="27614"/>
+        <pc:sldMkLst>
+          <pc:docMk/>
+          <pc:sldMk cId="2036194352" sldId="269"/>
+        </pc:sldMkLst>
+        <pc:spChg chg="del">
+          <ac:chgData name="Noémie Simon" userId="bcf751ccc0c63cc4" providerId="LiveId" clId="{D8646A5F-B639-4467-90AE-53976C914447}" dt="2026-06-02T20:33:17.488" v="110" actId="22"/>
+          <ac:spMkLst>
+            <pc:docMk/>
+            <pc:sldMk cId="2036194352" sldId="269"/>
+            <ac:spMk id="3" creationId="{8DB6A4F9-AF71-296C-A992-91D54ED70030}"/>
+          </ac:spMkLst>
+        </pc:spChg>
+        <pc:spChg chg="add mod">
+          <ac:chgData name="Noémie Simon" userId="bcf751ccc0c63cc4" providerId="LiveId" clId="{D8646A5F-B639-4467-90AE-53976C914447}" dt="2026-06-02T20:55:16.629" v="156" actId="478"/>
+          <ac:spMkLst>
+            <pc:docMk/>
+            <pc:sldMk cId="2036194352" sldId="269"/>
+            <ac:spMk id="7" creationId="{DCCFBE5E-470E-8AAF-8F23-FDD7777AA6DC}"/>
+          </ac:spMkLst>
+        </pc:spChg>
+        <pc:picChg chg="add del mod ord modCrop">
+          <ac:chgData name="Noémie Simon" userId="bcf751ccc0c63cc4" providerId="LiveId" clId="{D8646A5F-B639-4467-90AE-53976C914447}" dt="2026-06-02T20:55:16.629" v="156" actId="478"/>
+          <ac:picMkLst>
+            <pc:docMk/>
+            <pc:sldMk cId="2036194352" sldId="269"/>
+            <ac:picMk id="5" creationId="{EAF7FBEC-6756-951E-C204-502EE64EC167}"/>
+          </ac:picMkLst>
+        </pc:picChg>
+        <pc:picChg chg="add mod">
+          <ac:chgData name="Noémie Simon" userId="bcf751ccc0c63cc4" providerId="LiveId" clId="{D8646A5F-B639-4467-90AE-53976C914447}" dt="2026-06-02T20:55:29.016" v="158" actId="27614"/>
+          <ac:picMkLst>
+            <pc:docMk/>
+            <pc:sldMk cId="2036194352" sldId="269"/>
+            <ac:picMk id="9" creationId="{2CAB6DAC-E835-6F5C-E5D4-339A9645C7BE}"/>
+          </ac:picMkLst>
+        </pc:picChg>
+      </pc:sldChg>
+      <pc:sldChg chg="addSp delSp modSp new mod modClrScheme chgLayout">
+        <pc:chgData name="Noémie Simon" userId="bcf751ccc0c63cc4" providerId="LiveId" clId="{D8646A5F-B639-4467-90AE-53976C914447}" dt="2026-06-02T20:53:44.779" v="154" actId="207"/>
+        <pc:sldMkLst>
+          <pc:docMk/>
+          <pc:sldMk cId="2745853101" sldId="270"/>
+        </pc:sldMkLst>
+        <pc:spChg chg="del mod ord">
+          <ac:chgData name="Noémie Simon" userId="bcf751ccc0c63cc4" providerId="LiveId" clId="{D8646A5F-B639-4467-90AE-53976C914447}" dt="2026-06-02T20:46:36.389" v="120" actId="700"/>
+          <ac:spMkLst>
+            <pc:docMk/>
+            <pc:sldMk cId="2745853101" sldId="270"/>
+            <ac:spMk id="2" creationId="{358CB85D-264F-AA4D-DF2D-0738DFDDC6BC}"/>
+          </ac:spMkLst>
+        </pc:spChg>
+        <pc:spChg chg="del mod ord">
+          <ac:chgData name="Noémie Simon" userId="bcf751ccc0c63cc4" providerId="LiveId" clId="{D8646A5F-B639-4467-90AE-53976C914447}" dt="2026-06-02T20:46:36.389" v="120" actId="700"/>
+          <ac:spMkLst>
+            <pc:docMk/>
+            <pc:sldMk cId="2745853101" sldId="270"/>
+            <ac:spMk id="3" creationId="{F4598ED5-427D-7F34-541D-59507B9F33C2}"/>
+          </ac:spMkLst>
+        </pc:spChg>
+        <pc:spChg chg="add del mod ord">
+          <ac:chgData name="Noémie Simon" userId="bcf751ccc0c63cc4" providerId="LiveId" clId="{D8646A5F-B639-4467-90AE-53976C914447}" dt="2026-06-02T20:47:52.748" v="138" actId="478"/>
+          <ac:spMkLst>
+            <pc:docMk/>
+            <pc:sldMk cId="2745853101" sldId="270"/>
+            <ac:spMk id="4" creationId="{889D59ED-3880-CB75-910A-D8DD74D777B4}"/>
+          </ac:spMkLst>
+        </pc:spChg>
+        <pc:spChg chg="add mod ord">
+          <ac:chgData name="Noémie Simon" userId="bcf751ccc0c63cc4" providerId="LiveId" clId="{D8646A5F-B639-4467-90AE-53976C914447}" dt="2026-06-02T20:47:57.068" v="139" actId="1076"/>
+          <ac:spMkLst>
+            <pc:docMk/>
+            <pc:sldMk cId="2745853101" sldId="270"/>
+            <ac:spMk id="5" creationId="{E803951D-F116-DC10-6C43-19FFF7456671}"/>
+          </ac:spMkLst>
+        </pc:spChg>
+        <pc:spChg chg="add mod ord">
+          <ac:chgData name="Noémie Simon" userId="bcf751ccc0c63cc4" providerId="LiveId" clId="{D8646A5F-B639-4467-90AE-53976C914447}" dt="2026-06-02T20:53:44.779" v="154" actId="207"/>
+          <ac:spMkLst>
+            <pc:docMk/>
+            <pc:sldMk cId="2745853101" sldId="270"/>
+            <ac:spMk id="6" creationId="{B41B92A7-C4DD-19B5-4CEE-1DEFC7F961BB}"/>
           </ac:spMkLst>
         </pc:spChg>
       </pc:sldChg>
@@ -7766,435 +7890,6 @@
 </file>
 
 <file path=ppt/slides/slide10.xml><?xml version="1.0" encoding="utf-8"?>
-<p:sld xmlns:a="http://schemas.openxmlformats.org/drawingml/2006/main" xmlns:r="http://schemas.openxmlformats.org/officeDocument/2006/relationships" xmlns:p="http://schemas.openxmlformats.org/presentationml/2006/main">
-  <p:cSld>
-    <p:spTree>
-      <p:nvGrpSpPr>
-        <p:cNvPr id="1" name=""/>
-        <p:cNvGrpSpPr/>
-        <p:nvPr/>
-      </p:nvGrpSpPr>
-      <p:grpSpPr>
-        <a:xfrm>
-          <a:off x="0" y="0"/>
-          <a:ext cx="0" cy="0"/>
-          <a:chOff x="0" y="0"/>
-          <a:chExt cx="0" cy="0"/>
-        </a:xfrm>
-      </p:grpSpPr>
-      <p:sp>
-        <p:nvSpPr>
-          <p:cNvPr id="2" name="Title 1">
-            <a:extLst>
-              <a:ext uri="{FF2B5EF4-FFF2-40B4-BE49-F238E27FC236}">
-                <a16:creationId xmlns:a16="http://schemas.microsoft.com/office/drawing/2014/main" id="{8B6FD0A6-936D-1217-2307-54883D928515}"/>
-              </a:ext>
-            </a:extLst>
-          </p:cNvPr>
-          <p:cNvSpPr>
-            <a:spLocks noGrp="1"/>
-          </p:cNvSpPr>
-          <p:nvPr>
-            <p:ph type="title"/>
-          </p:nvPr>
-        </p:nvSpPr>
-        <p:spPr/>
-        <p:txBody>
-          <a:bodyPr>
-            <a:normAutofit/>
-          </a:bodyPr>
-          <a:lstStyle/>
-          <a:p>
-            <a:r>
-              <a:rPr lang="en-001" sz="4000" b="1" dirty="0"/>
-              <a:t>Activities occurring beyond the 15-minute city</a:t>
-            </a:r>
-            <a:endParaRPr lang="en-001" sz="4000" dirty="0"/>
-          </a:p>
-        </p:txBody>
-      </p:sp>
-      <p:pic>
-        <p:nvPicPr>
-          <p:cNvPr id="5" name="Content Placeholder 4">
-            <a:extLst>
-              <a:ext uri="{FF2B5EF4-FFF2-40B4-BE49-F238E27FC236}">
-                <a16:creationId xmlns:a16="http://schemas.microsoft.com/office/drawing/2014/main" id="{0A24CC37-D9A8-59DF-A14B-5BF03F157956}"/>
-              </a:ext>
-            </a:extLst>
-          </p:cNvPr>
-          <p:cNvPicPr>
-            <a:picLocks noGrp="1" noChangeAspect="1"/>
-          </p:cNvPicPr>
-          <p:nvPr>
-            <p:ph idx="1"/>
-          </p:nvPr>
-        </p:nvPicPr>
-        <p:blipFill>
-          <a:blip r:embed="rId2">
-            <a:extLst>
-              <a:ext uri="{28A0092B-C50C-407E-A947-70E740481C1C}">
-                <a14:useLocalDpi xmlns:a14="http://schemas.microsoft.com/office/drawing/2010/main" val="0"/>
-              </a:ext>
-            </a:extLst>
-          </a:blip>
-          <a:srcRect t="11781"/>
-          <a:stretch>
-            <a:fillRect/>
-          </a:stretch>
-        </p:blipFill>
-        <p:spPr>
-          <a:xfrm>
-            <a:off x="1431183" y="1470991"/>
-            <a:ext cx="8726608" cy="5281533"/>
-          </a:xfrm>
-          <a:prstGeom prst="rect">
-            <a:avLst/>
-          </a:prstGeom>
-        </p:spPr>
-      </p:pic>
-    </p:spTree>
-    <p:extLst>
-      <p:ext uri="{BB962C8B-B14F-4D97-AF65-F5344CB8AC3E}">
-        <p14:creationId xmlns:p14="http://schemas.microsoft.com/office/powerpoint/2010/main" val="3855054443"/>
-      </p:ext>
-    </p:extLst>
-  </p:cSld>
-  <p:clrMapOvr>
-    <a:masterClrMapping/>
-  </p:clrMapOvr>
-</p:sld>
-</file>
-
-<file path=ppt/slides/slide11.xml><?xml version="1.0" encoding="utf-8"?>
-<p:sld xmlns:a="http://schemas.openxmlformats.org/drawingml/2006/main" xmlns:r="http://schemas.openxmlformats.org/officeDocument/2006/relationships" xmlns:p="http://schemas.openxmlformats.org/presentationml/2006/main">
-  <p:cSld>
-    <p:spTree>
-      <p:nvGrpSpPr>
-        <p:cNvPr id="1" name=""/>
-        <p:cNvGrpSpPr/>
-        <p:nvPr/>
-      </p:nvGrpSpPr>
-      <p:grpSpPr>
-        <a:xfrm>
-          <a:off x="0" y="0"/>
-          <a:ext cx="0" cy="0"/>
-          <a:chOff x="0" y="0"/>
-          <a:chExt cx="0" cy="0"/>
-        </a:xfrm>
-      </p:grpSpPr>
-      <p:sp>
-        <p:nvSpPr>
-          <p:cNvPr id="2" name="Title 1">
-            <a:extLst>
-              <a:ext uri="{FF2B5EF4-FFF2-40B4-BE49-F238E27FC236}">
-                <a16:creationId xmlns:a16="http://schemas.microsoft.com/office/drawing/2014/main" id="{229A9C5E-D113-F410-1D52-CFEDFDD68709}"/>
-              </a:ext>
-            </a:extLst>
-          </p:cNvPr>
-          <p:cNvSpPr>
-            <a:spLocks noGrp="1"/>
-          </p:cNvSpPr>
-          <p:nvPr>
-            <p:ph type="title"/>
-          </p:nvPr>
-        </p:nvSpPr>
-        <p:spPr/>
-        <p:txBody>
-          <a:bodyPr/>
-          <a:lstStyle/>
-          <a:p>
-            <a:r>
-              <a:rPr lang="fr-CH" dirty="0"/>
-              <a:t>Challenges and Plan B</a:t>
-            </a:r>
-          </a:p>
-        </p:txBody>
-      </p:sp>
-      <p:sp>
-        <p:nvSpPr>
-          <p:cNvPr id="3" name="Content Placeholder 2">
-            <a:extLst>
-              <a:ext uri="{FF2B5EF4-FFF2-40B4-BE49-F238E27FC236}">
-                <a16:creationId xmlns:a16="http://schemas.microsoft.com/office/drawing/2014/main" id="{DBAEEBF5-C3D9-FA63-1735-E9C2F5C42998}"/>
-              </a:ext>
-            </a:extLst>
-          </p:cNvPr>
-          <p:cNvSpPr>
-            <a:spLocks noGrp="1"/>
-          </p:cNvSpPr>
-          <p:nvPr>
-            <p:ph idx="1"/>
-          </p:nvPr>
-        </p:nvSpPr>
-        <p:spPr/>
-        <p:txBody>
-          <a:bodyPr/>
-          <a:lstStyle/>
-          <a:p>
-            <a:r>
-              <a:rPr lang="fr-CH" dirty="0" err="1"/>
-              <a:t>Integration</a:t>
-            </a:r>
-            <a:r>
-              <a:rPr lang="fr-CH" dirty="0"/>
-              <a:t> of the ZVV time plan </a:t>
-            </a:r>
-          </a:p>
-          <a:p>
-            <a:pPr lvl="1"/>
-            <a:r>
-              <a:rPr lang="fr-CH" dirty="0"/>
-              <a:t>Heavy data set </a:t>
-            </a:r>
-          </a:p>
-          <a:p>
-            <a:pPr lvl="1"/>
-            <a:r>
-              <a:rPr lang="fr-CH" dirty="0"/>
-              <a:t>Add </a:t>
-            </a:r>
-            <a:r>
-              <a:rPr lang="fr-CH" dirty="0" err="1"/>
-              <a:t>unusefull</a:t>
-            </a:r>
-            <a:r>
-              <a:rPr lang="fr-CH" dirty="0"/>
-              <a:t> complication</a:t>
-            </a:r>
-            <a:endParaRPr lang="fr-CH" dirty="0">
-              <a:sym typeface="Wingdings" panose="05000000000000000000" pitchFamily="2" charset="2"/>
-            </a:endParaRPr>
-          </a:p>
-          <a:p>
-            <a:pPr>
-              <a:buFont typeface="Wingdings" panose="05000000000000000000" pitchFamily="2" charset="2"/>
-              <a:buChar char="à"/>
-            </a:pPr>
-            <a:r>
-              <a:rPr lang="fr-CH" dirty="0">
-                <a:sym typeface="Wingdings" panose="05000000000000000000" pitchFamily="2" charset="2"/>
-              </a:rPr>
-              <a:t> Use an estimation of the speed of the public transports (bus and tram) of 15 km/h </a:t>
-            </a:r>
-          </a:p>
-          <a:p>
-            <a:r>
-              <a:rPr lang="fr-CH" dirty="0">
-                <a:sym typeface="Wingdings" panose="05000000000000000000" pitchFamily="2" charset="2"/>
-              </a:rPr>
-              <a:t>Anonymisation of the data</a:t>
-            </a:r>
-          </a:p>
-          <a:p>
-            <a:pPr lvl="1"/>
-            <a:r>
-              <a:rPr lang="fr-CH" dirty="0">
-                <a:sym typeface="Wingdings" panose="05000000000000000000" pitchFamily="2" charset="2"/>
-              </a:rPr>
-              <a:t>With </a:t>
-            </a:r>
-            <a:r>
-              <a:rPr lang="fr-CH" dirty="0" err="1">
-                <a:sym typeface="Wingdings" panose="05000000000000000000" pitchFamily="2" charset="2"/>
-              </a:rPr>
-              <a:t>only</a:t>
-            </a:r>
-            <a:r>
-              <a:rPr lang="fr-CH" dirty="0">
-                <a:sym typeface="Wingdings" panose="05000000000000000000" pitchFamily="2" charset="2"/>
-              </a:rPr>
-              <a:t> a few </a:t>
-            </a:r>
-            <a:r>
-              <a:rPr lang="fr-CH" dirty="0" err="1">
-                <a:sym typeface="Wingdings" panose="05000000000000000000" pitchFamily="2" charset="2"/>
-              </a:rPr>
-              <a:t>visited</a:t>
-            </a:r>
-            <a:r>
-              <a:rPr lang="fr-CH" dirty="0">
-                <a:sym typeface="Wingdings" panose="05000000000000000000" pitchFamily="2" charset="2"/>
-              </a:rPr>
-              <a:t> points, </a:t>
-            </a:r>
-            <a:r>
-              <a:rPr lang="fr-CH" dirty="0" err="1">
-                <a:sym typeface="Wingdings" panose="05000000000000000000" pitchFamily="2" charset="2"/>
-              </a:rPr>
-              <a:t>it</a:t>
-            </a:r>
-            <a:r>
-              <a:rPr lang="fr-CH" dirty="0">
-                <a:sym typeface="Wingdings" panose="05000000000000000000" pitchFamily="2" charset="2"/>
-              </a:rPr>
-              <a:t> </a:t>
-            </a:r>
-            <a:r>
-              <a:rPr lang="fr-CH" dirty="0" err="1">
-                <a:sym typeface="Wingdings" panose="05000000000000000000" pitchFamily="2" charset="2"/>
-              </a:rPr>
-              <a:t>is</a:t>
-            </a:r>
-            <a:r>
-              <a:rPr lang="fr-CH" dirty="0">
-                <a:sym typeface="Wingdings" panose="05000000000000000000" pitchFamily="2" charset="2"/>
-              </a:rPr>
-              <a:t> possible to </a:t>
-            </a:r>
-            <a:r>
-              <a:rPr lang="fr-CH" dirty="0" err="1">
-                <a:sym typeface="Wingdings" panose="05000000000000000000" pitchFamily="2" charset="2"/>
-              </a:rPr>
-              <a:t>find</a:t>
-            </a:r>
-            <a:r>
-              <a:rPr lang="fr-CH" dirty="0">
-                <a:sym typeface="Wingdings" panose="05000000000000000000" pitchFamily="2" charset="2"/>
-              </a:rPr>
-              <a:t> out </a:t>
-            </a:r>
-            <a:r>
-              <a:rPr lang="fr-CH" dirty="0" err="1">
-                <a:sym typeface="Wingdings" panose="05000000000000000000" pitchFamily="2" charset="2"/>
-              </a:rPr>
-              <a:t>where</a:t>
-            </a:r>
-            <a:r>
-              <a:rPr lang="fr-CH" dirty="0">
-                <a:sym typeface="Wingdings" panose="05000000000000000000" pitchFamily="2" charset="2"/>
-              </a:rPr>
-              <a:t> the </a:t>
-            </a:r>
-            <a:r>
-              <a:rPr lang="fr-CH" dirty="0" err="1">
-                <a:sym typeface="Wingdings" panose="05000000000000000000" pitchFamily="2" charset="2"/>
-              </a:rPr>
-              <a:t>person</a:t>
-            </a:r>
-            <a:r>
-              <a:rPr lang="fr-CH" dirty="0">
-                <a:sym typeface="Wingdings" panose="05000000000000000000" pitchFamily="2" charset="2"/>
-              </a:rPr>
-              <a:t> </a:t>
-            </a:r>
-            <a:r>
-              <a:rPr lang="fr-CH" dirty="0" err="1">
-                <a:sym typeface="Wingdings" panose="05000000000000000000" pitchFamily="2" charset="2"/>
-              </a:rPr>
-              <a:t>lives</a:t>
-            </a:r>
-            <a:r>
-              <a:rPr lang="fr-CH" dirty="0">
-                <a:sym typeface="Wingdings" panose="05000000000000000000" pitchFamily="2" charset="2"/>
-              </a:rPr>
-              <a:t>/</a:t>
-            </a:r>
-            <a:r>
-              <a:rPr lang="fr-CH" dirty="0" err="1">
-                <a:sym typeface="Wingdings" panose="05000000000000000000" pitchFamily="2" charset="2"/>
-              </a:rPr>
-              <a:t>who</a:t>
-            </a:r>
-            <a:r>
-              <a:rPr lang="fr-CH" dirty="0">
-                <a:sym typeface="Wingdings" panose="05000000000000000000" pitchFamily="2" charset="2"/>
-              </a:rPr>
-              <a:t> </a:t>
-            </a:r>
-            <a:r>
-              <a:rPr lang="fr-CH" dirty="0" err="1">
-                <a:sym typeface="Wingdings" panose="05000000000000000000" pitchFamily="2" charset="2"/>
-              </a:rPr>
-              <a:t>they</a:t>
-            </a:r>
-            <a:r>
-              <a:rPr lang="fr-CH" dirty="0">
-                <a:sym typeface="Wingdings" panose="05000000000000000000" pitchFamily="2" charset="2"/>
-              </a:rPr>
-              <a:t> are</a:t>
-            </a:r>
-          </a:p>
-          <a:p>
-            <a:pPr marL="0" indent="0">
-              <a:buNone/>
-            </a:pPr>
-            <a:r>
-              <a:rPr lang="fr-CH" dirty="0">
-                <a:sym typeface="Wingdings" panose="05000000000000000000" pitchFamily="2" charset="2"/>
-              </a:rPr>
-              <a:t> Change the </a:t>
-            </a:r>
-            <a:r>
-              <a:rPr lang="fr-CH" dirty="0" err="1">
-                <a:sym typeface="Wingdings" panose="05000000000000000000" pitchFamily="2" charset="2"/>
-              </a:rPr>
-              <a:t>adress</a:t>
-            </a:r>
-            <a:r>
-              <a:rPr lang="fr-CH" dirty="0">
-                <a:sym typeface="Wingdings" panose="05000000000000000000" pitchFamily="2" charset="2"/>
-              </a:rPr>
-              <a:t> by a few blocks/</a:t>
-            </a:r>
-            <a:r>
-              <a:rPr lang="fr-CH" dirty="0" err="1">
-                <a:sym typeface="Wingdings" panose="05000000000000000000" pitchFamily="2" charset="2"/>
-              </a:rPr>
-              <a:t>streets</a:t>
-            </a:r>
-            <a:r>
-              <a:rPr lang="fr-CH" dirty="0">
-                <a:sym typeface="Wingdings" panose="05000000000000000000" pitchFamily="2" charset="2"/>
-              </a:rPr>
-              <a:t> (but </a:t>
-            </a:r>
-            <a:r>
-              <a:rPr lang="fr-CH" dirty="0" err="1">
-                <a:sym typeface="Wingdings" panose="05000000000000000000" pitchFamily="2" charset="2"/>
-              </a:rPr>
-              <a:t>still</a:t>
-            </a:r>
-            <a:r>
-              <a:rPr lang="fr-CH" dirty="0">
-                <a:sym typeface="Wingdings" panose="05000000000000000000" pitchFamily="2" charset="2"/>
-              </a:rPr>
-              <a:t> not </a:t>
-            </a:r>
-            <a:r>
-              <a:rPr lang="fr-CH" dirty="0" err="1">
-                <a:sym typeface="Wingdings" panose="05000000000000000000" pitchFamily="2" charset="2"/>
-              </a:rPr>
-              <a:t>ideal</a:t>
-            </a:r>
-            <a:r>
-              <a:rPr lang="fr-CH" dirty="0">
-                <a:sym typeface="Wingdings" panose="05000000000000000000" pitchFamily="2" charset="2"/>
-              </a:rPr>
-              <a:t>) </a:t>
-            </a:r>
-          </a:p>
-          <a:p>
-            <a:pPr marL="0" indent="0">
-              <a:buNone/>
-            </a:pPr>
-            <a:endParaRPr lang="fr-CH" dirty="0"/>
-          </a:p>
-        </p:txBody>
-      </p:sp>
-    </p:spTree>
-    <p:extLst>
-      <p:ext uri="{BB962C8B-B14F-4D97-AF65-F5344CB8AC3E}">
-        <p14:creationId xmlns:p14="http://schemas.microsoft.com/office/powerpoint/2010/main" val="2357305363"/>
-      </p:ext>
-    </p:extLst>
-  </p:cSld>
-  <p:clrMapOvr>
-    <a:masterClrMapping/>
-  </p:clrMapOvr>
-</p:sld>
-</file>
-
-<file path=ppt/slides/slide2.xml><?xml version="1.0" encoding="utf-8"?>
 <p:sld xmlns:a="http://schemas.openxmlformats.org/drawingml/2006/main" xmlns:r="http://schemas.openxmlformats.org/officeDocument/2006/relationships" xmlns:p="http://schemas.openxmlformats.org/presentationml/2006/main" show="0">
   <p:cSld>
     <p:spTree>
@@ -9757,7 +9452,7 @@
 </p:sld>
 </file>
 
-<file path=ppt/slides/slide3.xml><?xml version="1.0" encoding="utf-8"?>
+<file path=ppt/slides/slide11.xml><?xml version="1.0" encoding="utf-8"?>
 <p:sld xmlns:a="http://schemas.openxmlformats.org/drawingml/2006/main" xmlns:r="http://schemas.openxmlformats.org/officeDocument/2006/relationships" xmlns:p="http://schemas.openxmlformats.org/presentationml/2006/main" show="0">
   <p:cSld>
     <p:bg>
@@ -11202,7 +10897,212 @@
 </p:sld>
 </file>
 
-<file path=ppt/slides/slide4.xml><?xml version="1.0" encoding="utf-8"?>
+<file path=ppt/slides/slide12.xml><?xml version="1.0" encoding="utf-8"?>
+<p:sld xmlns:a="http://schemas.openxmlformats.org/drawingml/2006/main" xmlns:r="http://schemas.openxmlformats.org/officeDocument/2006/relationships" xmlns:p="http://schemas.openxmlformats.org/presentationml/2006/main" show="0">
+  <p:cSld>
+    <p:spTree>
+      <p:nvGrpSpPr>
+        <p:cNvPr id="1" name="">
+          <a:extLst>
+            <a:ext uri="{FF2B5EF4-FFF2-40B4-BE49-F238E27FC236}">
+              <a16:creationId xmlns:a16="http://schemas.microsoft.com/office/drawing/2014/main" id="{3D423E1E-BDBE-7890-99F7-75EB4E2501C1}"/>
+            </a:ext>
+          </a:extLst>
+        </p:cNvPr>
+        <p:cNvGrpSpPr/>
+        <p:nvPr/>
+      </p:nvGrpSpPr>
+      <p:grpSpPr>
+        <a:xfrm>
+          <a:off x="0" y="0"/>
+          <a:ext cx="0" cy="0"/>
+          <a:chOff x="0" y="0"/>
+          <a:chExt cx="0" cy="0"/>
+        </a:xfrm>
+      </p:grpSpPr>
+      <p:sp>
+        <p:nvSpPr>
+          <p:cNvPr id="2" name="Title 1">
+            <a:extLst>
+              <a:ext uri="{FF2B5EF4-FFF2-40B4-BE49-F238E27FC236}">
+                <a16:creationId xmlns:a16="http://schemas.microsoft.com/office/drawing/2014/main" id="{F68A396A-E78B-8B83-BCD1-2000A3ACC94E}"/>
+              </a:ext>
+            </a:extLst>
+          </p:cNvPr>
+          <p:cNvSpPr>
+            <a:spLocks noGrp="1"/>
+          </p:cNvSpPr>
+          <p:nvPr>
+            <p:ph type="title"/>
+          </p:nvPr>
+        </p:nvSpPr>
+        <p:spPr>
+          <a:xfrm>
+            <a:off x="838200" y="713312"/>
+            <a:ext cx="4038600" cy="3472607"/>
+          </a:xfrm>
+        </p:spPr>
+        <p:txBody>
+          <a:bodyPr>
+            <a:normAutofit/>
+          </a:bodyPr>
+          <a:lstStyle/>
+          <a:p>
+            <a:r>
+              <a:rPr lang="en-001" dirty="0"/>
+              <a:t>Best Possible Outcome</a:t>
+            </a:r>
+          </a:p>
+        </p:txBody>
+      </p:sp>
+      <p:sp>
+        <p:nvSpPr>
+          <p:cNvPr id="24" name="Content Placeholder 2">
+            <a:extLst>
+              <a:ext uri="{FF2B5EF4-FFF2-40B4-BE49-F238E27FC236}">
+                <a16:creationId xmlns:a16="http://schemas.microsoft.com/office/drawing/2014/main" id="{220A022F-93D1-8C5A-87A5-E8C8242FA292}"/>
+              </a:ext>
+            </a:extLst>
+          </p:cNvPr>
+          <p:cNvSpPr>
+            <a:spLocks noGrp="1"/>
+          </p:cNvSpPr>
+          <p:nvPr>
+            <p:ph idx="1"/>
+          </p:nvPr>
+        </p:nvSpPr>
+        <p:spPr>
+          <a:xfrm>
+            <a:off x="4876801" y="713313"/>
+            <a:ext cx="6477000" cy="3472607"/>
+          </a:xfrm>
+        </p:spPr>
+        <p:txBody>
+          <a:bodyPr anchor="ctr">
+            <a:normAutofit fontScale="92500" lnSpcReduction="10000"/>
+          </a:bodyPr>
+          <a:lstStyle/>
+          <a:p>
+            <a:pPr marL="0" indent="0">
+              <a:buNone/>
+            </a:pPr>
+            <a:r>
+              <a:rPr lang="en-001" sz="3200" dirty="0"/>
+              <a:t>We expect to:</a:t>
+            </a:r>
+          </a:p>
+          <a:p>
+            <a:r>
+              <a:rPr lang="en-001" sz="3200" dirty="0"/>
+              <a:t>Quantify the proportion of local vs non-local activities </a:t>
+            </a:r>
+          </a:p>
+          <a:p>
+            <a:r>
+              <a:rPr lang="en-001" sz="3200" dirty="0"/>
+              <a:t>Identify activity types that exceed the 15-minute threshold </a:t>
+            </a:r>
+          </a:p>
+          <a:p>
+            <a:r>
+              <a:rPr lang="en-001" sz="3200" dirty="0"/>
+              <a:t>Evaluate whether mobility is driven more by accessibility or by personal preferences and habits</a:t>
+            </a:r>
+          </a:p>
+        </p:txBody>
+      </p:sp>
+      <p:sp>
+        <p:nvSpPr>
+          <p:cNvPr id="3" name="Rectangle 2">
+            <a:extLst>
+              <a:ext uri="{FF2B5EF4-FFF2-40B4-BE49-F238E27FC236}">
+                <a16:creationId xmlns:a16="http://schemas.microsoft.com/office/drawing/2014/main" id="{7054B78A-D08B-EF49-5DCE-3E78CEFBEEF3}"/>
+              </a:ext>
+            </a:extLst>
+          </p:cNvPr>
+          <p:cNvSpPr/>
+          <p:nvPr/>
+        </p:nvSpPr>
+        <p:spPr>
+          <a:xfrm>
+            <a:off x="0" y="4795520"/>
+            <a:ext cx="12192000" cy="1561737"/>
+          </a:xfrm>
+          <a:prstGeom prst="rect">
+            <a:avLst/>
+          </a:prstGeom>
+          <a:solidFill>
+            <a:srgbClr val="F4F4F4"/>
+          </a:solidFill>
+          <a:ln>
+            <a:noFill/>
+          </a:ln>
+        </p:spPr>
+        <p:style>
+          <a:lnRef idx="2">
+            <a:schemeClr val="accent1">
+              <a:shade val="15000"/>
+            </a:schemeClr>
+          </a:lnRef>
+          <a:fillRef idx="1">
+            <a:schemeClr val="accent1"/>
+          </a:fillRef>
+          <a:effectRef idx="0">
+            <a:schemeClr val="accent1"/>
+          </a:effectRef>
+          <a:fontRef idx="minor">
+            <a:schemeClr val="lt1"/>
+          </a:fontRef>
+        </p:style>
+        <p:txBody>
+          <a:bodyPr rtlCol="0" anchor="ctr"/>
+          <a:lstStyle/>
+          <a:p>
+            <a:pPr algn="ctr"/>
+            <a:r>
+              <a:rPr lang="en-001" sz="2200" b="1" dirty="0">
+                <a:solidFill>
+                  <a:schemeClr val="tx1"/>
+                </a:solidFill>
+              </a:rPr>
+              <a:t>Hypothesis:</a:t>
+            </a:r>
+            <a:r>
+              <a:rPr lang="en-001" sz="2200" dirty="0">
+                <a:solidFill>
+                  <a:schemeClr val="tx1"/>
+                </a:solidFill>
+              </a:rPr>
+              <a:t> Even in Zurich, many social and professional activities </a:t>
+            </a:r>
+          </a:p>
+          <a:p>
+            <a:pPr algn="ctr"/>
+            <a:r>
+              <a:rPr lang="en-001" sz="2200" dirty="0">
+                <a:solidFill>
+                  <a:schemeClr val="tx1"/>
+                </a:solidFill>
+              </a:rPr>
+              <a:t>occur beyond the theoretically accessible area</a:t>
+            </a:r>
+          </a:p>
+        </p:txBody>
+      </p:sp>
+    </p:spTree>
+    <p:extLst>
+      <p:ext uri="{BB962C8B-B14F-4D97-AF65-F5344CB8AC3E}">
+        <p14:creationId xmlns:p14="http://schemas.microsoft.com/office/powerpoint/2010/main" val="2129016569"/>
+      </p:ext>
+    </p:extLst>
+  </p:cSld>
+  <p:clrMapOvr>
+    <a:masterClrMapping/>
+  </p:clrMapOvr>
+</p:sld>
+</file>
+
+<file path=ppt/slides/slide2.xml><?xml version="1.0" encoding="utf-8"?>
 <p:sld xmlns:a="http://schemas.openxmlformats.org/drawingml/2006/main" xmlns:r="http://schemas.openxmlformats.org/officeDocument/2006/relationships" xmlns:p="http://schemas.openxmlformats.org/presentationml/2006/main">
   <p:cSld>
     <p:spTree>
@@ -13351,17 +13251,9 @@
 </p:sld>
 </file>
 
-<file path=ppt/slides/slide5.xml><?xml version="1.0" encoding="utf-8"?>
+<file path=ppt/slides/slide3.xml><?xml version="1.0" encoding="utf-8"?>
 <p:sld xmlns:a="http://schemas.openxmlformats.org/drawingml/2006/main" xmlns:r="http://schemas.openxmlformats.org/officeDocument/2006/relationships" xmlns:p="http://schemas.openxmlformats.org/presentationml/2006/main">
   <p:cSld>
-    <p:bg>
-      <p:bgPr>
-        <a:solidFill>
-          <a:schemeClr val="bg1"/>
-        </a:solidFill>
-        <a:effectLst/>
-      </p:bgPr>
-    </p:bg>
     <p:spTree>
       <p:nvGrpSpPr>
         <p:cNvPr id="1" name=""/>
@@ -13376,1037 +13268,12 @@
           <a:chExt cx="0" cy="0"/>
         </a:xfrm>
       </p:grpSpPr>
-      <p:sp useBgFill="1">
+      <p:sp>
         <p:nvSpPr>
-          <p:cNvPr id="29" name="Rectangle 28">
+          <p:cNvPr id="5" name="Content Placeholder 4">
             <a:extLst>
               <a:ext uri="{FF2B5EF4-FFF2-40B4-BE49-F238E27FC236}">
-                <a16:creationId xmlns:a16="http://schemas.microsoft.com/office/drawing/2014/main" id="{17718681-A12E-49D6-9925-DD7C68176D61}"/>
-              </a:ext>
-              <a:ext uri="{C183D7F6-B498-43B3-948B-1728B52AA6E4}">
-                <adec:decorative xmlns:adec="http://schemas.microsoft.com/office/drawing/2017/decorative" val="1"/>
-              </a:ext>
-            </a:extLst>
-          </p:cNvPr>
-          <p:cNvSpPr>
-            <a:spLocks noGrp="1" noRot="1" noChangeAspect="1" noMove="1" noResize="1" noEditPoints="1" noAdjustHandles="1" noChangeArrowheads="1" noChangeShapeType="1" noTextEdit="1"/>
-          </p:cNvSpPr>
-          <p:nvPr>
-            <p:extLst>
-              <p:ext uri="{386F3935-93C4-4BCD-93E2-E3B085C9AB24}">
-                <p16:designElem xmlns:p16="http://schemas.microsoft.com/office/powerpoint/2015/main" val="1"/>
-              </p:ext>
-            </p:extLst>
-          </p:nvPr>
-        </p:nvSpPr>
-        <p:spPr>
-          <a:xfrm>
-            <a:off x="0" y="0"/>
-            <a:ext cx="12188952" cy="6858000"/>
-          </a:xfrm>
-          <a:prstGeom prst="rect">
-            <a:avLst/>
-          </a:prstGeom>
-          <a:ln>
-            <a:noFill/>
-          </a:ln>
-        </p:spPr>
-        <p:style>
-          <a:lnRef idx="2">
-            <a:schemeClr val="accent1">
-              <a:shade val="50000"/>
-            </a:schemeClr>
-          </a:lnRef>
-          <a:fillRef idx="1">
-            <a:schemeClr val="accent1"/>
-          </a:fillRef>
-          <a:effectRef idx="0">
-            <a:schemeClr val="accent1"/>
-          </a:effectRef>
-          <a:fontRef idx="minor">
-            <a:schemeClr val="lt1"/>
-          </a:fontRef>
-        </p:style>
-        <p:txBody>
-          <a:bodyPr rtlCol="0" anchor="ctr"/>
-          <a:lstStyle/>
-          <a:p>
-            <a:pPr algn="ctr"/>
-            <a:endParaRPr lang="en-US"/>
-          </a:p>
-        </p:txBody>
-      </p:sp>
-      <p:sp>
-        <p:nvSpPr>
-          <p:cNvPr id="31" name="Freeform: Shape 30">
-            <a:extLst>
-              <a:ext uri="{FF2B5EF4-FFF2-40B4-BE49-F238E27FC236}">
-                <a16:creationId xmlns:a16="http://schemas.microsoft.com/office/drawing/2014/main" id="{FBD77573-9EF2-4C35-8285-A1CF6FBB0EA5}"/>
-              </a:ext>
-              <a:ext uri="{C183D7F6-B498-43B3-948B-1728B52AA6E4}">
-                <adec:decorative xmlns:adec="http://schemas.microsoft.com/office/drawing/2017/decorative" val="1"/>
-              </a:ext>
-            </a:extLst>
-          </p:cNvPr>
-          <p:cNvSpPr>
-            <a:spLocks noGrp="1" noRot="1" noChangeAspect="1" noMove="1" noResize="1" noEditPoints="1" noAdjustHandles="1" noChangeArrowheads="1" noChangeShapeType="1" noTextEdit="1"/>
-          </p:cNvSpPr>
-          <p:nvPr>
-            <p:extLst>
-              <p:ext uri="{386F3935-93C4-4BCD-93E2-E3B085C9AB24}">
-                <p16:designElem xmlns:p16="http://schemas.microsoft.com/office/powerpoint/2015/main" val="1"/>
-              </p:ext>
-            </p:extLst>
-          </p:nvPr>
-        </p:nvSpPr>
-        <p:spPr>
-          <a:xfrm flipH="1">
-            <a:off x="1" y="0"/>
-            <a:ext cx="5511704" cy="6858000"/>
-          </a:xfrm>
-          <a:custGeom>
-            <a:avLst/>
-            <a:gdLst>
-              <a:gd name="connsiteX0" fmla="*/ 5511704 w 5511704"/>
-              <a:gd name="connsiteY0" fmla="*/ 0 h 6886576"/>
-              <a:gd name="connsiteX1" fmla="*/ 1008599 w 5511704"/>
-              <a:gd name="connsiteY1" fmla="*/ 0 h 6886576"/>
-              <a:gd name="connsiteX2" fmla="*/ 1310975 w 5511704"/>
-              <a:gd name="connsiteY2" fmla="*/ 110728 h 6886576"/>
-              <a:gd name="connsiteX3" fmla="*/ 1267362 w 5511704"/>
-              <a:gd name="connsiteY3" fmla="*/ 135731 h 6886576"/>
-              <a:gd name="connsiteX4" fmla="*/ 1005692 w 5511704"/>
-              <a:gd name="connsiteY4" fmla="*/ 71437 h 6886576"/>
-              <a:gd name="connsiteX5" fmla="*/ 953358 w 5511704"/>
-              <a:gd name="connsiteY5" fmla="*/ 89297 h 6886576"/>
-              <a:gd name="connsiteX6" fmla="*/ 979525 w 5511704"/>
-              <a:gd name="connsiteY6" fmla="*/ 164307 h 6886576"/>
-              <a:gd name="connsiteX7" fmla="*/ 1092915 w 5511704"/>
-              <a:gd name="connsiteY7" fmla="*/ 192882 h 6886576"/>
-              <a:gd name="connsiteX8" fmla="*/ 1270270 w 5511704"/>
-              <a:gd name="connsiteY8" fmla="*/ 375047 h 6886576"/>
-              <a:gd name="connsiteX9" fmla="*/ 1002784 w 5511704"/>
-              <a:gd name="connsiteY9" fmla="*/ 353615 h 6886576"/>
-              <a:gd name="connsiteX10" fmla="*/ 956265 w 5511704"/>
-              <a:gd name="connsiteY10" fmla="*/ 396479 h 6886576"/>
-              <a:gd name="connsiteX11" fmla="*/ 938820 w 5511704"/>
-              <a:gd name="connsiteY11" fmla="*/ 453629 h 6886576"/>
-              <a:gd name="connsiteX12" fmla="*/ 860319 w 5511704"/>
-              <a:gd name="connsiteY12" fmla="*/ 360759 h 6886576"/>
-              <a:gd name="connsiteX13" fmla="*/ 793447 w 5511704"/>
-              <a:gd name="connsiteY13" fmla="*/ 335757 h 6886576"/>
-              <a:gd name="connsiteX14" fmla="*/ 773095 w 5511704"/>
-              <a:gd name="connsiteY14" fmla="*/ 417910 h 6886576"/>
-              <a:gd name="connsiteX15" fmla="*/ 834151 w 5511704"/>
-              <a:gd name="connsiteY15" fmla="*/ 507206 h 6886576"/>
-              <a:gd name="connsiteX16" fmla="*/ 996969 w 5511704"/>
-              <a:gd name="connsiteY16" fmla="*/ 560785 h 6886576"/>
-              <a:gd name="connsiteX17" fmla="*/ 822522 w 5511704"/>
-              <a:gd name="connsiteY17" fmla="*/ 560785 h 6886576"/>
-              <a:gd name="connsiteX18" fmla="*/ 621908 w 5511704"/>
-              <a:gd name="connsiteY18" fmla="*/ 525066 h 6886576"/>
-              <a:gd name="connsiteX19" fmla="*/ 409664 w 5511704"/>
-              <a:gd name="connsiteY19" fmla="*/ 535781 h 6886576"/>
-              <a:gd name="connsiteX20" fmla="*/ 209049 w 5511704"/>
-              <a:gd name="connsiteY20" fmla="*/ 464344 h 6886576"/>
-              <a:gd name="connsiteX21" fmla="*/ 5527 w 5511704"/>
-              <a:gd name="connsiteY21" fmla="*/ 467916 h 6886576"/>
-              <a:gd name="connsiteX22" fmla="*/ 906838 w 5511704"/>
-              <a:gd name="connsiteY22" fmla="*/ 914400 h 6886576"/>
-              <a:gd name="connsiteX23" fmla="*/ 863226 w 5511704"/>
-              <a:gd name="connsiteY23" fmla="*/ 925116 h 6886576"/>
-              <a:gd name="connsiteX24" fmla="*/ 805077 w 5511704"/>
-              <a:gd name="connsiteY24" fmla="*/ 953691 h 6886576"/>
-              <a:gd name="connsiteX25" fmla="*/ 848689 w 5511704"/>
-              <a:gd name="connsiteY25" fmla="*/ 1010841 h 6886576"/>
-              <a:gd name="connsiteX26" fmla="*/ 1084193 w 5511704"/>
-              <a:gd name="connsiteY26" fmla="*/ 1117997 h 6886576"/>
-              <a:gd name="connsiteX27" fmla="*/ 1142342 w 5511704"/>
-              <a:gd name="connsiteY27" fmla="*/ 1225153 h 6886576"/>
-              <a:gd name="connsiteX28" fmla="*/ 1069655 w 5511704"/>
-              <a:gd name="connsiteY28" fmla="*/ 1214438 h 6886576"/>
-              <a:gd name="connsiteX29" fmla="*/ 1005692 w 5511704"/>
-              <a:gd name="connsiteY29" fmla="*/ 1235869 h 6886576"/>
-              <a:gd name="connsiteX30" fmla="*/ 1031858 w 5511704"/>
-              <a:gd name="connsiteY30" fmla="*/ 1371600 h 6886576"/>
-              <a:gd name="connsiteX31" fmla="*/ 1366216 w 5511704"/>
-              <a:gd name="connsiteY31" fmla="*/ 1546622 h 6886576"/>
-              <a:gd name="connsiteX32" fmla="*/ 1395290 w 5511704"/>
-              <a:gd name="connsiteY32" fmla="*/ 1603772 h 6886576"/>
-              <a:gd name="connsiteX33" fmla="*/ 1354586 w 5511704"/>
-              <a:gd name="connsiteY33" fmla="*/ 1643063 h 6886576"/>
-              <a:gd name="connsiteX34" fmla="*/ 1247011 w 5511704"/>
-              <a:gd name="connsiteY34" fmla="*/ 1664494 h 6886576"/>
-              <a:gd name="connsiteX35" fmla="*/ 1398198 w 5511704"/>
-              <a:gd name="connsiteY35" fmla="*/ 1857375 h 6886576"/>
-              <a:gd name="connsiteX36" fmla="*/ 1453440 w 5511704"/>
-              <a:gd name="connsiteY36" fmla="*/ 1910954 h 6886576"/>
-              <a:gd name="connsiteX37" fmla="*/ 1549386 w 5511704"/>
-              <a:gd name="connsiteY37" fmla="*/ 1993106 h 6886576"/>
-              <a:gd name="connsiteX38" fmla="*/ 1549386 w 5511704"/>
-              <a:gd name="connsiteY38" fmla="*/ 2021681 h 6886576"/>
-              <a:gd name="connsiteX39" fmla="*/ 1421458 w 5511704"/>
-              <a:gd name="connsiteY39" fmla="*/ 2110978 h 6886576"/>
-              <a:gd name="connsiteX40" fmla="*/ 1188861 w 5511704"/>
-              <a:gd name="connsiteY40" fmla="*/ 2085976 h 6886576"/>
-              <a:gd name="connsiteX41" fmla="*/ 1531941 w 5511704"/>
-              <a:gd name="connsiteY41" fmla="*/ 2218135 h 6886576"/>
-              <a:gd name="connsiteX42" fmla="*/ 421293 w 5511704"/>
-              <a:gd name="connsiteY42" fmla="*/ 1900238 h 6886576"/>
-              <a:gd name="connsiteX43" fmla="*/ 491072 w 5511704"/>
-              <a:gd name="connsiteY43" fmla="*/ 1982391 h 6886576"/>
-              <a:gd name="connsiteX44" fmla="*/ 880671 w 5511704"/>
-              <a:gd name="connsiteY44" fmla="*/ 2200276 h 6886576"/>
-              <a:gd name="connsiteX45" fmla="*/ 991154 w 5511704"/>
-              <a:gd name="connsiteY45" fmla="*/ 2336007 h 6886576"/>
-              <a:gd name="connsiteX46" fmla="*/ 1107453 w 5511704"/>
-              <a:gd name="connsiteY46" fmla="*/ 2411016 h 6886576"/>
-              <a:gd name="connsiteX47" fmla="*/ 1270270 w 5511704"/>
-              <a:gd name="connsiteY47" fmla="*/ 2411016 h 6886576"/>
-              <a:gd name="connsiteX48" fmla="*/ 1386568 w 5511704"/>
-              <a:gd name="connsiteY48" fmla="*/ 2528889 h 6886576"/>
-              <a:gd name="connsiteX49" fmla="*/ 1267362 w 5511704"/>
-              <a:gd name="connsiteY49" fmla="*/ 2553891 h 6886576"/>
-              <a:gd name="connsiteX50" fmla="*/ 1127805 w 5511704"/>
-              <a:gd name="connsiteY50" fmla="*/ 2536032 h 6886576"/>
-              <a:gd name="connsiteX51" fmla="*/ 970802 w 5511704"/>
-              <a:gd name="connsiteY51" fmla="*/ 2575322 h 6886576"/>
-              <a:gd name="connsiteX52" fmla="*/ 825429 w 5511704"/>
-              <a:gd name="connsiteY52" fmla="*/ 2543176 h 6886576"/>
-              <a:gd name="connsiteX53" fmla="*/ 650982 w 5511704"/>
-              <a:gd name="connsiteY53" fmla="*/ 2564607 h 6886576"/>
-              <a:gd name="connsiteX54" fmla="*/ 595740 w 5511704"/>
-              <a:gd name="connsiteY54" fmla="*/ 2703909 h 6886576"/>
-              <a:gd name="connsiteX55" fmla="*/ 578296 w 5511704"/>
-              <a:gd name="connsiteY55" fmla="*/ 2714626 h 6886576"/>
-              <a:gd name="connsiteX56" fmla="*/ 255568 w 5511704"/>
-              <a:gd name="connsiteY56" fmla="*/ 2936081 h 6886576"/>
-              <a:gd name="connsiteX57" fmla="*/ 165437 w 5511704"/>
-              <a:gd name="connsiteY57" fmla="*/ 2953941 h 6886576"/>
-              <a:gd name="connsiteX58" fmla="*/ 697501 w 5511704"/>
-              <a:gd name="connsiteY58" fmla="*/ 3343275 h 6886576"/>
-              <a:gd name="connsiteX59" fmla="*/ 339884 w 5511704"/>
-              <a:gd name="connsiteY59" fmla="*/ 3243263 h 6886576"/>
-              <a:gd name="connsiteX60" fmla="*/ 290458 w 5511704"/>
-              <a:gd name="connsiteY60" fmla="*/ 3407569 h 6886576"/>
-              <a:gd name="connsiteX61" fmla="*/ 459090 w 5511704"/>
-              <a:gd name="connsiteY61" fmla="*/ 3554016 h 6886576"/>
-              <a:gd name="connsiteX62" fmla="*/ 520147 w 5511704"/>
-              <a:gd name="connsiteY62" fmla="*/ 3843338 h 6886576"/>
-              <a:gd name="connsiteX63" fmla="*/ 491072 w 5511704"/>
-              <a:gd name="connsiteY63" fmla="*/ 4107657 h 6886576"/>
-              <a:gd name="connsiteX64" fmla="*/ 418386 w 5511704"/>
-              <a:gd name="connsiteY64" fmla="*/ 4189810 h 6886576"/>
-              <a:gd name="connsiteX65" fmla="*/ 313718 w 5511704"/>
-              <a:gd name="connsiteY65" fmla="*/ 4339829 h 6886576"/>
-              <a:gd name="connsiteX66" fmla="*/ 249753 w 5511704"/>
-              <a:gd name="connsiteY66" fmla="*/ 4432698 h 6886576"/>
-              <a:gd name="connsiteX67" fmla="*/ 25879 w 5511704"/>
-              <a:gd name="connsiteY67" fmla="*/ 4396979 h 6886576"/>
-              <a:gd name="connsiteX68" fmla="*/ 325347 w 5511704"/>
-              <a:gd name="connsiteY68" fmla="*/ 4632722 h 6886576"/>
-              <a:gd name="connsiteX69" fmla="*/ 84029 w 5511704"/>
-              <a:gd name="connsiteY69" fmla="*/ 4604147 h 6886576"/>
-              <a:gd name="connsiteX70" fmla="*/ 5527 w 5511704"/>
-              <a:gd name="connsiteY70" fmla="*/ 4622007 h 6886576"/>
-              <a:gd name="connsiteX71" fmla="*/ 49139 w 5511704"/>
-              <a:gd name="connsiteY71" fmla="*/ 4697016 h 6886576"/>
-              <a:gd name="connsiteX72" fmla="*/ 226494 w 5511704"/>
-              <a:gd name="connsiteY72" fmla="*/ 4825604 h 6886576"/>
-              <a:gd name="connsiteX73" fmla="*/ 592833 w 5511704"/>
-              <a:gd name="connsiteY73" fmla="*/ 5175647 h 6886576"/>
-              <a:gd name="connsiteX74" fmla="*/ 238123 w 5511704"/>
-              <a:gd name="connsiteY74" fmla="*/ 5014913 h 6886576"/>
-              <a:gd name="connsiteX75" fmla="*/ 610278 w 5511704"/>
-              <a:gd name="connsiteY75" fmla="*/ 5375673 h 6886576"/>
-              <a:gd name="connsiteX76" fmla="*/ 691686 w 5511704"/>
-              <a:gd name="connsiteY76" fmla="*/ 5497116 h 6886576"/>
-              <a:gd name="connsiteX77" fmla="*/ 860319 w 5511704"/>
-              <a:gd name="connsiteY77" fmla="*/ 5793582 h 6886576"/>
-              <a:gd name="connsiteX78" fmla="*/ 851597 w 5511704"/>
-              <a:gd name="connsiteY78" fmla="*/ 5825729 h 6886576"/>
-              <a:gd name="connsiteX79" fmla="*/ 659704 w 5511704"/>
-              <a:gd name="connsiteY79" fmla="*/ 5779295 h 6886576"/>
-              <a:gd name="connsiteX80" fmla="*/ 909746 w 5511704"/>
-              <a:gd name="connsiteY80" fmla="*/ 6029326 h 6886576"/>
-              <a:gd name="connsiteX81" fmla="*/ 1168509 w 5511704"/>
-              <a:gd name="connsiteY81" fmla="*/ 6222207 h 6886576"/>
-              <a:gd name="connsiteX82" fmla="*/ 985339 w 5511704"/>
-              <a:gd name="connsiteY82" fmla="*/ 6193632 h 6886576"/>
-              <a:gd name="connsiteX83" fmla="*/ 732391 w 5511704"/>
-              <a:gd name="connsiteY83" fmla="*/ 6082904 h 6886576"/>
-              <a:gd name="connsiteX84" fmla="*/ 645167 w 5511704"/>
-              <a:gd name="connsiteY84" fmla="*/ 6125766 h 6886576"/>
-              <a:gd name="connsiteX85" fmla="*/ 883579 w 5511704"/>
-              <a:gd name="connsiteY85" fmla="*/ 6307932 h 6886576"/>
-              <a:gd name="connsiteX86" fmla="*/ 1020229 w 5511704"/>
-              <a:gd name="connsiteY86" fmla="*/ 6393657 h 6886576"/>
-              <a:gd name="connsiteX87" fmla="*/ 1075471 w 5511704"/>
-              <a:gd name="connsiteY87" fmla="*/ 6457950 h 6886576"/>
-              <a:gd name="connsiteX88" fmla="*/ 1232473 w 5511704"/>
-              <a:gd name="connsiteY88" fmla="*/ 6686551 h 6886576"/>
-              <a:gd name="connsiteX89" fmla="*/ 1592997 w 5511704"/>
-              <a:gd name="connsiteY89" fmla="*/ 6886576 h 6886576"/>
-              <a:gd name="connsiteX90" fmla="*/ 5511704 w 5511704"/>
-              <a:gd name="connsiteY90" fmla="*/ 6886576 h 6886576"/>
-            </a:gdLst>
-            <a:ahLst/>
-            <a:cxnLst>
-              <a:cxn ang="0">
-                <a:pos x="connsiteX0" y="connsiteY0"/>
-              </a:cxn>
-              <a:cxn ang="0">
-                <a:pos x="connsiteX1" y="connsiteY1"/>
-              </a:cxn>
-              <a:cxn ang="0">
-                <a:pos x="connsiteX2" y="connsiteY2"/>
-              </a:cxn>
-              <a:cxn ang="0">
-                <a:pos x="connsiteX3" y="connsiteY3"/>
-              </a:cxn>
-              <a:cxn ang="0">
-                <a:pos x="connsiteX4" y="connsiteY4"/>
-              </a:cxn>
-              <a:cxn ang="0">
-                <a:pos x="connsiteX5" y="connsiteY5"/>
-              </a:cxn>
-              <a:cxn ang="0">
-                <a:pos x="connsiteX6" y="connsiteY6"/>
-              </a:cxn>
-              <a:cxn ang="0">
-                <a:pos x="connsiteX7" y="connsiteY7"/>
-              </a:cxn>
-              <a:cxn ang="0">
-                <a:pos x="connsiteX8" y="connsiteY8"/>
-              </a:cxn>
-              <a:cxn ang="0">
-                <a:pos x="connsiteX9" y="connsiteY9"/>
-              </a:cxn>
-              <a:cxn ang="0">
-                <a:pos x="connsiteX10" y="connsiteY10"/>
-              </a:cxn>
-              <a:cxn ang="0">
-                <a:pos x="connsiteX11" y="connsiteY11"/>
-              </a:cxn>
-              <a:cxn ang="0">
-                <a:pos x="connsiteX12" y="connsiteY12"/>
-              </a:cxn>
-              <a:cxn ang="0">
-                <a:pos x="connsiteX13" y="connsiteY13"/>
-              </a:cxn>
-              <a:cxn ang="0">
-                <a:pos x="connsiteX14" y="connsiteY14"/>
-              </a:cxn>
-              <a:cxn ang="0">
-                <a:pos x="connsiteX15" y="connsiteY15"/>
-              </a:cxn>
-              <a:cxn ang="0">
-                <a:pos x="connsiteX16" y="connsiteY16"/>
-              </a:cxn>
-              <a:cxn ang="0">
-                <a:pos x="connsiteX17" y="connsiteY17"/>
-              </a:cxn>
-              <a:cxn ang="0">
-                <a:pos x="connsiteX18" y="connsiteY18"/>
-              </a:cxn>
-              <a:cxn ang="0">
-                <a:pos x="connsiteX19" y="connsiteY19"/>
-              </a:cxn>
-              <a:cxn ang="0">
-                <a:pos x="connsiteX20" y="connsiteY20"/>
-              </a:cxn>
-              <a:cxn ang="0">
-                <a:pos x="connsiteX21" y="connsiteY21"/>
-              </a:cxn>
-              <a:cxn ang="0">
-                <a:pos x="connsiteX22" y="connsiteY22"/>
-              </a:cxn>
-              <a:cxn ang="0">
-                <a:pos x="connsiteX23" y="connsiteY23"/>
-              </a:cxn>
-              <a:cxn ang="0">
-                <a:pos x="connsiteX24" y="connsiteY24"/>
-              </a:cxn>
-              <a:cxn ang="0">
-                <a:pos x="connsiteX25" y="connsiteY25"/>
-              </a:cxn>
-              <a:cxn ang="0">
-                <a:pos x="connsiteX26" y="connsiteY26"/>
-              </a:cxn>
-              <a:cxn ang="0">
-                <a:pos x="connsiteX27" y="connsiteY27"/>
-              </a:cxn>
-              <a:cxn ang="0">
-                <a:pos x="connsiteX28" y="connsiteY28"/>
-              </a:cxn>
-              <a:cxn ang="0">
-                <a:pos x="connsiteX29" y="connsiteY29"/>
-              </a:cxn>
-              <a:cxn ang="0">
-                <a:pos x="connsiteX30" y="connsiteY30"/>
-              </a:cxn>
-              <a:cxn ang="0">
-                <a:pos x="connsiteX31" y="connsiteY31"/>
-              </a:cxn>
-              <a:cxn ang="0">
-                <a:pos x="connsiteX32" y="connsiteY32"/>
-              </a:cxn>
-              <a:cxn ang="0">
-                <a:pos x="connsiteX33" y="connsiteY33"/>
-              </a:cxn>
-              <a:cxn ang="0">
-                <a:pos x="connsiteX34" y="connsiteY34"/>
-              </a:cxn>
-              <a:cxn ang="0">
-                <a:pos x="connsiteX35" y="connsiteY35"/>
-              </a:cxn>
-              <a:cxn ang="0">
-                <a:pos x="connsiteX36" y="connsiteY36"/>
-              </a:cxn>
-              <a:cxn ang="0">
-                <a:pos x="connsiteX37" y="connsiteY37"/>
-              </a:cxn>
-              <a:cxn ang="0">
-                <a:pos x="connsiteX38" y="connsiteY38"/>
-              </a:cxn>
-              <a:cxn ang="0">
-                <a:pos x="connsiteX39" y="connsiteY39"/>
-              </a:cxn>
-              <a:cxn ang="0">
-                <a:pos x="connsiteX40" y="connsiteY40"/>
-              </a:cxn>
-              <a:cxn ang="0">
-                <a:pos x="connsiteX41" y="connsiteY41"/>
-              </a:cxn>
-              <a:cxn ang="0">
-                <a:pos x="connsiteX42" y="connsiteY42"/>
-              </a:cxn>
-              <a:cxn ang="0">
-                <a:pos x="connsiteX43" y="connsiteY43"/>
-              </a:cxn>
-              <a:cxn ang="0">
-                <a:pos x="connsiteX44" y="connsiteY44"/>
-              </a:cxn>
-              <a:cxn ang="0">
-                <a:pos x="connsiteX45" y="connsiteY45"/>
-              </a:cxn>
-              <a:cxn ang="0">
-                <a:pos x="connsiteX46" y="connsiteY46"/>
-              </a:cxn>
-              <a:cxn ang="0">
-                <a:pos x="connsiteX47" y="connsiteY47"/>
-              </a:cxn>
-              <a:cxn ang="0">
-                <a:pos x="connsiteX48" y="connsiteY48"/>
-              </a:cxn>
-              <a:cxn ang="0">
-                <a:pos x="connsiteX49" y="connsiteY49"/>
-              </a:cxn>
-              <a:cxn ang="0">
-                <a:pos x="connsiteX50" y="connsiteY50"/>
-              </a:cxn>
-              <a:cxn ang="0">
-                <a:pos x="connsiteX51" y="connsiteY51"/>
-              </a:cxn>
-              <a:cxn ang="0">
-                <a:pos x="connsiteX52" y="connsiteY52"/>
-              </a:cxn>
-              <a:cxn ang="0">
-                <a:pos x="connsiteX53" y="connsiteY53"/>
-              </a:cxn>
-              <a:cxn ang="0">
-                <a:pos x="connsiteX54" y="connsiteY54"/>
-              </a:cxn>
-              <a:cxn ang="0">
-                <a:pos x="connsiteX55" y="connsiteY55"/>
-              </a:cxn>
-              <a:cxn ang="0">
-                <a:pos x="connsiteX56" y="connsiteY56"/>
-              </a:cxn>
-              <a:cxn ang="0">
-                <a:pos x="connsiteX57" y="connsiteY57"/>
-              </a:cxn>
-              <a:cxn ang="0">
-                <a:pos x="connsiteX58" y="connsiteY58"/>
-              </a:cxn>
-              <a:cxn ang="0">
-                <a:pos x="connsiteX59" y="connsiteY59"/>
-              </a:cxn>
-              <a:cxn ang="0">
-                <a:pos x="connsiteX60" y="connsiteY60"/>
-              </a:cxn>
-              <a:cxn ang="0">
-                <a:pos x="connsiteX61" y="connsiteY61"/>
-              </a:cxn>
-              <a:cxn ang="0">
-                <a:pos x="connsiteX62" y="connsiteY62"/>
-              </a:cxn>
-              <a:cxn ang="0">
-                <a:pos x="connsiteX63" y="connsiteY63"/>
-              </a:cxn>
-              <a:cxn ang="0">
-                <a:pos x="connsiteX64" y="connsiteY64"/>
-              </a:cxn>
-              <a:cxn ang="0">
-                <a:pos x="connsiteX65" y="connsiteY65"/>
-              </a:cxn>
-              <a:cxn ang="0">
-                <a:pos x="connsiteX66" y="connsiteY66"/>
-              </a:cxn>
-              <a:cxn ang="0">
-                <a:pos x="connsiteX67" y="connsiteY67"/>
-              </a:cxn>
-              <a:cxn ang="0">
-                <a:pos x="connsiteX68" y="connsiteY68"/>
-              </a:cxn>
-              <a:cxn ang="0">
-                <a:pos x="connsiteX69" y="connsiteY69"/>
-              </a:cxn>
-              <a:cxn ang="0">
-                <a:pos x="connsiteX70" y="connsiteY70"/>
-              </a:cxn>
-              <a:cxn ang="0">
-                <a:pos x="connsiteX71" y="connsiteY71"/>
-              </a:cxn>
-              <a:cxn ang="0">
-                <a:pos x="connsiteX72" y="connsiteY72"/>
-              </a:cxn>
-              <a:cxn ang="0">
-                <a:pos x="connsiteX73" y="connsiteY73"/>
-              </a:cxn>
-              <a:cxn ang="0">
-                <a:pos x="connsiteX74" y="connsiteY74"/>
-              </a:cxn>
-              <a:cxn ang="0">
-                <a:pos x="connsiteX75" y="connsiteY75"/>
-              </a:cxn>
-              <a:cxn ang="0">
-                <a:pos x="connsiteX76" y="connsiteY76"/>
-              </a:cxn>
-              <a:cxn ang="0">
-                <a:pos x="connsiteX77" y="connsiteY77"/>
-              </a:cxn>
-              <a:cxn ang="0">
-                <a:pos x="connsiteX78" y="connsiteY78"/>
-              </a:cxn>
-              <a:cxn ang="0">
-                <a:pos x="connsiteX79" y="connsiteY79"/>
-              </a:cxn>
-              <a:cxn ang="0">
-                <a:pos x="connsiteX80" y="connsiteY80"/>
-              </a:cxn>
-              <a:cxn ang="0">
-                <a:pos x="connsiteX81" y="connsiteY81"/>
-              </a:cxn>
-              <a:cxn ang="0">
-                <a:pos x="connsiteX82" y="connsiteY82"/>
-              </a:cxn>
-              <a:cxn ang="0">
-                <a:pos x="connsiteX83" y="connsiteY83"/>
-              </a:cxn>
-              <a:cxn ang="0">
-                <a:pos x="connsiteX84" y="connsiteY84"/>
-              </a:cxn>
-              <a:cxn ang="0">
-                <a:pos x="connsiteX85" y="connsiteY85"/>
-              </a:cxn>
-              <a:cxn ang="0">
-                <a:pos x="connsiteX86" y="connsiteY86"/>
-              </a:cxn>
-              <a:cxn ang="0">
-                <a:pos x="connsiteX87" y="connsiteY87"/>
-              </a:cxn>
-              <a:cxn ang="0">
-                <a:pos x="connsiteX88" y="connsiteY88"/>
-              </a:cxn>
-              <a:cxn ang="0">
-                <a:pos x="connsiteX89" y="connsiteY89"/>
-              </a:cxn>
-              <a:cxn ang="0">
-                <a:pos x="connsiteX90" y="connsiteY90"/>
-              </a:cxn>
-            </a:cxnLst>
-            <a:rect l="l" t="t" r="r" b="b"/>
-            <a:pathLst>
-              <a:path w="5511704" h="6886576">
-                <a:moveTo>
-                  <a:pt x="5511704" y="0"/>
-                </a:moveTo>
-                <a:lnTo>
-                  <a:pt x="1008599" y="0"/>
-                </a:lnTo>
-                <a:cubicBezTo>
-                  <a:pt x="1110360" y="35719"/>
-                  <a:pt x="1209214" y="78581"/>
-                  <a:pt x="1310975" y="110728"/>
-                </a:cubicBezTo>
-                <a:cubicBezTo>
-                  <a:pt x="1296437" y="146447"/>
-                  <a:pt x="1281900" y="139303"/>
-                  <a:pt x="1267362" y="135731"/>
-                </a:cubicBezTo>
-                <a:cubicBezTo>
-                  <a:pt x="1180139" y="121445"/>
-                  <a:pt x="1090008" y="110728"/>
-                  <a:pt x="1005692" y="71437"/>
-                </a:cubicBezTo>
-                <a:cubicBezTo>
-                  <a:pt x="985339" y="64294"/>
-                  <a:pt x="962080" y="64294"/>
-                  <a:pt x="953358" y="89297"/>
-                </a:cubicBezTo>
-                <a:cubicBezTo>
-                  <a:pt x="938820" y="125016"/>
-                  <a:pt x="959172" y="146447"/>
-                  <a:pt x="979525" y="164307"/>
-                </a:cubicBezTo>
-                <a:cubicBezTo>
-                  <a:pt x="1014414" y="196453"/>
-                  <a:pt x="1055118" y="189310"/>
-                  <a:pt x="1092915" y="192882"/>
-                </a:cubicBezTo>
-                <a:cubicBezTo>
-                  <a:pt x="1197583" y="210741"/>
-                  <a:pt x="1247011" y="260747"/>
-                  <a:pt x="1270270" y="375047"/>
-                </a:cubicBezTo>
-                <a:cubicBezTo>
-                  <a:pt x="1180139" y="328613"/>
-                  <a:pt x="1090008" y="385763"/>
-                  <a:pt x="1002784" y="353615"/>
-                </a:cubicBezTo>
-                <a:cubicBezTo>
-                  <a:pt x="979525" y="346472"/>
-                  <a:pt x="944635" y="357188"/>
-                  <a:pt x="956265" y="396479"/>
-                </a:cubicBezTo>
-                <a:cubicBezTo>
-                  <a:pt x="967894" y="432198"/>
-                  <a:pt x="1005692" y="460772"/>
-                  <a:pt x="938820" y="453629"/>
-                </a:cubicBezTo>
-                <a:cubicBezTo>
-                  <a:pt x="889393" y="450056"/>
-                  <a:pt x="874856" y="407194"/>
-                  <a:pt x="860319" y="360759"/>
-                </a:cubicBezTo>
-                <a:cubicBezTo>
-                  <a:pt x="848689" y="335757"/>
-                  <a:pt x="816707" y="321469"/>
-                  <a:pt x="793447" y="335757"/>
-                </a:cubicBezTo>
-                <a:cubicBezTo>
-                  <a:pt x="764373" y="350044"/>
-                  <a:pt x="773095" y="389335"/>
-                  <a:pt x="773095" y="417910"/>
-                </a:cubicBezTo>
-                <a:cubicBezTo>
-                  <a:pt x="770187" y="471488"/>
-                  <a:pt x="793447" y="496491"/>
-                  <a:pt x="834151" y="507206"/>
-                </a:cubicBezTo>
-                <a:cubicBezTo>
-                  <a:pt x="883579" y="521494"/>
-                  <a:pt x="933005" y="539354"/>
-                  <a:pt x="996969" y="560785"/>
-                </a:cubicBezTo>
-                <a:cubicBezTo>
-                  <a:pt x="927190" y="596503"/>
-                  <a:pt x="874856" y="589360"/>
-                  <a:pt x="822522" y="560785"/>
-                </a:cubicBezTo>
-                <a:cubicBezTo>
-                  <a:pt x="758558" y="528637"/>
-                  <a:pt x="674242" y="485775"/>
-                  <a:pt x="621908" y="525066"/>
-                </a:cubicBezTo>
-                <a:cubicBezTo>
-                  <a:pt x="543407" y="582216"/>
-                  <a:pt x="479443" y="546497"/>
-                  <a:pt x="409664" y="535781"/>
-                </a:cubicBezTo>
-                <a:cubicBezTo>
-                  <a:pt x="264290" y="514350"/>
-                  <a:pt x="354422" y="482204"/>
-                  <a:pt x="209049" y="464344"/>
-                </a:cubicBezTo>
-                <a:cubicBezTo>
-                  <a:pt x="150900" y="457200"/>
-                  <a:pt x="89843" y="428625"/>
-                  <a:pt x="5527" y="467916"/>
-                </a:cubicBezTo>
-                <a:cubicBezTo>
-                  <a:pt x="386404" y="675085"/>
-                  <a:pt x="566666" y="660797"/>
-                  <a:pt x="906838" y="914400"/>
-                </a:cubicBezTo>
-                <a:cubicBezTo>
-                  <a:pt x="892301" y="939404"/>
-                  <a:pt x="877764" y="928688"/>
-                  <a:pt x="863226" y="925116"/>
-                </a:cubicBezTo>
-                <a:cubicBezTo>
-                  <a:pt x="839967" y="921544"/>
-                  <a:pt x="810892" y="907256"/>
-                  <a:pt x="805077" y="953691"/>
-                </a:cubicBezTo>
-                <a:cubicBezTo>
-                  <a:pt x="802169" y="989410"/>
-                  <a:pt x="819615" y="1007269"/>
-                  <a:pt x="848689" y="1010841"/>
-                </a:cubicBezTo>
-                <a:cubicBezTo>
-                  <a:pt x="933005" y="1025129"/>
-                  <a:pt x="1008599" y="1075135"/>
-                  <a:pt x="1084193" y="1117997"/>
-                </a:cubicBezTo>
-                <a:cubicBezTo>
-                  <a:pt x="1119082" y="1135857"/>
-                  <a:pt x="1156879" y="1160860"/>
-                  <a:pt x="1142342" y="1225153"/>
-                </a:cubicBezTo>
-                <a:cubicBezTo>
-                  <a:pt x="1113268" y="1243013"/>
-                  <a:pt x="1092915" y="1218009"/>
-                  <a:pt x="1069655" y="1214438"/>
-                </a:cubicBezTo>
-                <a:cubicBezTo>
-                  <a:pt x="1046396" y="1210866"/>
-                  <a:pt x="991154" y="1225153"/>
-                  <a:pt x="1005692" y="1235869"/>
-                </a:cubicBezTo>
-                <a:cubicBezTo>
-                  <a:pt x="1072563" y="1275159"/>
-                  <a:pt x="950450" y="1371600"/>
-                  <a:pt x="1031858" y="1371600"/>
-                </a:cubicBezTo>
-                <a:cubicBezTo>
-                  <a:pt x="1165601" y="1371600"/>
-                  <a:pt x="1238288" y="1543050"/>
-                  <a:pt x="1366216" y="1546622"/>
-                </a:cubicBezTo>
-                <a:cubicBezTo>
-                  <a:pt x="1386568" y="1546622"/>
-                  <a:pt x="1395290" y="1578770"/>
-                  <a:pt x="1395290" y="1603772"/>
-                </a:cubicBezTo>
-                <a:cubicBezTo>
-                  <a:pt x="1395290" y="1635920"/>
-                  <a:pt x="1374939" y="1639491"/>
-                  <a:pt x="1354586" y="1643063"/>
-                </a:cubicBezTo>
-                <a:cubicBezTo>
-                  <a:pt x="1322604" y="1646635"/>
-                  <a:pt x="1287715" y="1603772"/>
-                  <a:pt x="1247011" y="1664494"/>
-                </a:cubicBezTo>
-                <a:cubicBezTo>
-                  <a:pt x="1322604" y="1700213"/>
-                  <a:pt x="1401105" y="1735932"/>
-                  <a:pt x="1398198" y="1857375"/>
-                </a:cubicBezTo>
-                <a:cubicBezTo>
-                  <a:pt x="1398198" y="1889523"/>
-                  <a:pt x="1430180" y="1903810"/>
-                  <a:pt x="1453440" y="1910954"/>
-                </a:cubicBezTo>
-                <a:cubicBezTo>
-                  <a:pt x="1494144" y="1925241"/>
-                  <a:pt x="1526126" y="1946673"/>
-                  <a:pt x="1549386" y="1993106"/>
-                </a:cubicBezTo>
-                <a:cubicBezTo>
-                  <a:pt x="1549386" y="2003822"/>
-                  <a:pt x="1549386" y="2010966"/>
-                  <a:pt x="1549386" y="2021681"/>
-                </a:cubicBezTo>
-                <a:cubicBezTo>
-                  <a:pt x="1543571" y="2132410"/>
-                  <a:pt x="1485422" y="2128838"/>
-                  <a:pt x="1421458" y="2110978"/>
-                </a:cubicBezTo>
-                <a:cubicBezTo>
-                  <a:pt x="1345864" y="2089547"/>
-                  <a:pt x="1270270" y="2046685"/>
-                  <a:pt x="1188861" y="2085976"/>
-                </a:cubicBezTo>
-                <a:cubicBezTo>
-                  <a:pt x="1302252" y="2139554"/>
-                  <a:pt x="1427272" y="2143126"/>
-                  <a:pt x="1531941" y="2218135"/>
-                </a:cubicBezTo>
-                <a:cubicBezTo>
-                  <a:pt x="1142342" y="2232422"/>
-                  <a:pt x="799262" y="1993106"/>
-                  <a:pt x="421293" y="1900238"/>
-                </a:cubicBezTo>
-                <a:cubicBezTo>
-                  <a:pt x="432923" y="1960960"/>
-                  <a:pt x="464905" y="1975247"/>
-                  <a:pt x="491072" y="1982391"/>
-                </a:cubicBezTo>
-                <a:cubicBezTo>
-                  <a:pt x="630630" y="2028825"/>
-                  <a:pt x="752743" y="2121695"/>
-                  <a:pt x="880671" y="2200276"/>
-                </a:cubicBezTo>
-                <a:cubicBezTo>
-                  <a:pt x="933005" y="2232422"/>
-                  <a:pt x="970802" y="2268142"/>
-                  <a:pt x="991154" y="2336007"/>
-                </a:cubicBezTo>
-                <a:cubicBezTo>
-                  <a:pt x="1008599" y="2400300"/>
-                  <a:pt x="1043489" y="2428875"/>
-                  <a:pt x="1107453" y="2411016"/>
-                </a:cubicBezTo>
-                <a:cubicBezTo>
-                  <a:pt x="1159787" y="2396729"/>
-                  <a:pt x="1215029" y="2403873"/>
-                  <a:pt x="1270270" y="2411016"/>
-                </a:cubicBezTo>
-                <a:cubicBezTo>
-                  <a:pt x="1331326" y="2418160"/>
-                  <a:pt x="1401105" y="2489597"/>
-                  <a:pt x="1386568" y="2528889"/>
-                </a:cubicBezTo>
-                <a:cubicBezTo>
-                  <a:pt x="1357494" y="2593182"/>
-                  <a:pt x="1308067" y="2561035"/>
-                  <a:pt x="1267362" y="2553891"/>
-                </a:cubicBezTo>
-                <a:cubicBezTo>
-                  <a:pt x="1217936" y="2546748"/>
-                  <a:pt x="1127805" y="2528889"/>
-                  <a:pt x="1127805" y="2536032"/>
-                </a:cubicBezTo>
-                <a:cubicBezTo>
-                  <a:pt x="1095822" y="2696766"/>
-                  <a:pt x="1023136" y="2575322"/>
-                  <a:pt x="970802" y="2575322"/>
-                </a:cubicBezTo>
-                <a:cubicBezTo>
-                  <a:pt x="921375" y="2575322"/>
-                  <a:pt x="871949" y="2557463"/>
-                  <a:pt x="825429" y="2543176"/>
-                </a:cubicBezTo>
-                <a:cubicBezTo>
-                  <a:pt x="764373" y="2525316"/>
-                  <a:pt x="709132" y="2557463"/>
-                  <a:pt x="650982" y="2564607"/>
-                </a:cubicBezTo>
-                <a:cubicBezTo>
-                  <a:pt x="598648" y="2571751"/>
-                  <a:pt x="627722" y="2664620"/>
-                  <a:pt x="595740" y="2703909"/>
-                </a:cubicBezTo>
-                <a:cubicBezTo>
-                  <a:pt x="589926" y="2714626"/>
-                  <a:pt x="584111" y="2714626"/>
-                  <a:pt x="578296" y="2714626"/>
-                </a:cubicBezTo>
-                <a:cubicBezTo>
-                  <a:pt x="560851" y="2993232"/>
-                  <a:pt x="255568" y="2925366"/>
-                  <a:pt x="255568" y="2936081"/>
-                </a:cubicBezTo>
-                <a:cubicBezTo>
-                  <a:pt x="229401" y="2953941"/>
-                  <a:pt x="197419" y="2911079"/>
-                  <a:pt x="165437" y="2953941"/>
-                </a:cubicBezTo>
-                <a:cubicBezTo>
-                  <a:pt x="302087" y="3150394"/>
-                  <a:pt x="511425" y="3196828"/>
-                  <a:pt x="697501" y="3343275"/>
-                </a:cubicBezTo>
-                <a:cubicBezTo>
-                  <a:pt x="543407" y="3393282"/>
-                  <a:pt x="453275" y="3221832"/>
-                  <a:pt x="339884" y="3243263"/>
-                </a:cubicBezTo>
-                <a:cubicBezTo>
-                  <a:pt x="284643" y="3296842"/>
-                  <a:pt x="450368" y="3382566"/>
-                  <a:pt x="290458" y="3407569"/>
-                </a:cubicBezTo>
-                <a:cubicBezTo>
-                  <a:pt x="360236" y="3454004"/>
-                  <a:pt x="409664" y="3500439"/>
-                  <a:pt x="459090" y="3554016"/>
-                </a:cubicBezTo>
-                <a:cubicBezTo>
-                  <a:pt x="543407" y="3650457"/>
-                  <a:pt x="560851" y="3714751"/>
-                  <a:pt x="520147" y="3843338"/>
-                </a:cubicBezTo>
-                <a:cubicBezTo>
-                  <a:pt x="493979" y="3929063"/>
-                  <a:pt x="456183" y="4007645"/>
-                  <a:pt x="491072" y="4107657"/>
-                </a:cubicBezTo>
-                <a:cubicBezTo>
-                  <a:pt x="514332" y="4175522"/>
-                  <a:pt x="505609" y="4221957"/>
-                  <a:pt x="418386" y="4189810"/>
-                </a:cubicBezTo>
-                <a:cubicBezTo>
-                  <a:pt x="325347" y="4157663"/>
-                  <a:pt x="290458" y="4218386"/>
-                  <a:pt x="313718" y="4339829"/>
-                </a:cubicBezTo>
-                <a:cubicBezTo>
-                  <a:pt x="328254" y="4418410"/>
-                  <a:pt x="313718" y="4443413"/>
-                  <a:pt x="249753" y="4432698"/>
-                </a:cubicBezTo>
-                <a:cubicBezTo>
-                  <a:pt x="179975" y="4421982"/>
-                  <a:pt x="113103" y="4371976"/>
-                  <a:pt x="25879" y="4396979"/>
-                </a:cubicBezTo>
-                <a:cubicBezTo>
-                  <a:pt x="95658" y="4539854"/>
-                  <a:pt x="243939" y="4496991"/>
-                  <a:pt x="325347" y="4632722"/>
-                </a:cubicBezTo>
-                <a:cubicBezTo>
-                  <a:pt x="229401" y="4632722"/>
-                  <a:pt x="153807" y="4632722"/>
-                  <a:pt x="84029" y="4604147"/>
-                </a:cubicBezTo>
-                <a:cubicBezTo>
-                  <a:pt x="54954" y="4593433"/>
-                  <a:pt x="22972" y="4579145"/>
-                  <a:pt x="5527" y="4622007"/>
-                </a:cubicBezTo>
-                <a:cubicBezTo>
-                  <a:pt x="-14826" y="4672014"/>
-                  <a:pt x="25879" y="4689872"/>
-                  <a:pt x="49139" y="4697016"/>
-                </a:cubicBezTo>
-                <a:cubicBezTo>
-                  <a:pt x="116011" y="4722019"/>
-                  <a:pt x="168344" y="4779170"/>
-                  <a:pt x="226494" y="4825604"/>
-                </a:cubicBezTo>
-                <a:cubicBezTo>
-                  <a:pt x="351514" y="4925616"/>
-                  <a:pt x="488165" y="5011341"/>
-                  <a:pt x="592833" y="5175647"/>
-                </a:cubicBezTo>
-                <a:cubicBezTo>
-                  <a:pt x="461997" y="5132785"/>
-                  <a:pt x="363144" y="5032772"/>
-                  <a:pt x="238123" y="5014913"/>
-                </a:cubicBezTo>
-                <a:cubicBezTo>
-                  <a:pt x="345700" y="5164932"/>
-                  <a:pt x="482350" y="5264944"/>
-                  <a:pt x="610278" y="5375673"/>
-                </a:cubicBezTo>
-                <a:cubicBezTo>
-                  <a:pt x="648075" y="5407819"/>
-                  <a:pt x="685872" y="5429250"/>
-                  <a:pt x="691686" y="5497116"/>
-                </a:cubicBezTo>
-                <a:cubicBezTo>
-                  <a:pt x="709132" y="5629276"/>
-                  <a:pt x="755650" y="5736432"/>
-                  <a:pt x="860319" y="5793582"/>
-                </a:cubicBezTo>
-                <a:cubicBezTo>
-                  <a:pt x="860319" y="5793582"/>
-                  <a:pt x="854504" y="5815013"/>
-                  <a:pt x="851597" y="5825729"/>
-                </a:cubicBezTo>
-                <a:cubicBezTo>
-                  <a:pt x="787632" y="5829301"/>
-                  <a:pt x="738206" y="5750720"/>
-                  <a:pt x="659704" y="5779295"/>
-                </a:cubicBezTo>
-                <a:cubicBezTo>
-                  <a:pt x="738206" y="5886451"/>
-                  <a:pt x="802169" y="5979319"/>
-                  <a:pt x="909746" y="6029326"/>
-                </a:cubicBezTo>
-                <a:cubicBezTo>
-                  <a:pt x="996969" y="6068616"/>
-                  <a:pt x="1104545" y="6093620"/>
-                  <a:pt x="1168509" y="6222207"/>
-                </a:cubicBezTo>
-                <a:cubicBezTo>
-                  <a:pt x="1095822" y="6247210"/>
-                  <a:pt x="1040581" y="6215063"/>
-                  <a:pt x="985339" y="6193632"/>
-                </a:cubicBezTo>
-                <a:cubicBezTo>
-                  <a:pt x="901023" y="6157913"/>
-                  <a:pt x="816707" y="6118623"/>
-                  <a:pt x="732391" y="6082904"/>
-                </a:cubicBezTo>
-                <a:cubicBezTo>
-                  <a:pt x="700408" y="6068616"/>
-                  <a:pt x="665519" y="6061472"/>
-                  <a:pt x="645167" y="6125766"/>
-                </a:cubicBezTo>
-                <a:cubicBezTo>
-                  <a:pt x="752743" y="6140053"/>
-                  <a:pt x="816707" y="6225779"/>
-                  <a:pt x="883579" y="6307932"/>
-                </a:cubicBezTo>
-                <a:cubicBezTo>
-                  <a:pt x="921375" y="6354366"/>
-                  <a:pt x="953358" y="6415088"/>
-                  <a:pt x="1020229" y="6393657"/>
-                </a:cubicBezTo>
-                <a:cubicBezTo>
-                  <a:pt x="1055118" y="6382942"/>
-                  <a:pt x="1078378" y="6415088"/>
-                  <a:pt x="1075471" y="6457950"/>
-                </a:cubicBezTo>
-                <a:cubicBezTo>
-                  <a:pt x="1060933" y="6607970"/>
-                  <a:pt x="1145250" y="6657976"/>
-                  <a:pt x="1232473" y="6686551"/>
-                </a:cubicBezTo>
-                <a:cubicBezTo>
-                  <a:pt x="1360401" y="6729413"/>
-                  <a:pt x="1473792" y="6815138"/>
-                  <a:pt x="1592997" y="6886576"/>
-                </a:cubicBezTo>
-                <a:lnTo>
-                  <a:pt x="5511704" y="6886576"/>
-                </a:lnTo>
-                <a:close/>
-              </a:path>
-            </a:pathLst>
-          </a:custGeom>
-          <a:solidFill>
-            <a:schemeClr val="bg2">
-              <a:alpha val="50000"/>
-            </a:schemeClr>
-          </a:solidFill>
-          <a:ln w="32707" cap="flat">
-            <a:noFill/>
-            <a:prstDash val="solid"/>
-            <a:miter/>
-          </a:ln>
-        </p:spPr>
-        <p:txBody>
-          <a:bodyPr rtlCol="0" anchor="ctr"/>
-          <a:lstStyle/>
-          <a:p>
-            <a:endParaRPr lang="en-US" dirty="0"/>
-          </a:p>
-        </p:txBody>
-      </p:sp>
-      <p:sp>
-        <p:nvSpPr>
-          <p:cNvPr id="2" name="Title 1">
-            <a:extLst>
-              <a:ext uri="{FF2B5EF4-FFF2-40B4-BE49-F238E27FC236}">
-                <a16:creationId xmlns:a16="http://schemas.microsoft.com/office/drawing/2014/main" id="{3ED5FDDA-FB89-7C42-000C-DFB890DC4FCA}"/>
+                <a16:creationId xmlns:a16="http://schemas.microsoft.com/office/drawing/2014/main" id="{E803951D-F116-DC10-6C43-19FFF7456671}"/>
               </a:ext>
             </a:extLst>
           </p:cNvPr>
@@ -14414,27 +13281,34 @@
             <a:spLocks noGrp="1"/>
           </p:cNvSpPr>
           <p:nvPr>
-            <p:ph type="title"/>
+            <p:ph sz="half" idx="1"/>
           </p:nvPr>
         </p:nvSpPr>
         <p:spPr>
           <a:xfrm>
-            <a:off x="838200" y="713312"/>
-            <a:ext cx="4038600" cy="5431376"/>
+            <a:off x="1203960" y="2426144"/>
+            <a:ext cx="3907536" cy="1231456"/>
           </a:xfrm>
         </p:spPr>
         <p:txBody>
           <a:bodyPr>
-            <a:normAutofit/>
+            <a:normAutofit lnSpcReduction="10000"/>
           </a:bodyPr>
           <a:lstStyle/>
           <a:p>
-            <a:r>
-              <a:rPr lang="fr-CH" dirty="0" err="1"/>
+            <a:pPr marL="0" indent="0">
+              <a:buNone/>
+            </a:pPr>
+            <a:r>
+              <a:rPr lang="fr-CH" sz="4400" dirty="0" err="1">
+                <a:latin typeface="+mj-lt"/>
+              </a:rPr>
               <a:t>Research</a:t>
             </a:r>
             <a:r>
-              <a:rPr lang="fr-CH" dirty="0"/>
+              <a:rPr lang="fr-CH" sz="4400" dirty="0">
+                <a:latin typeface="+mj-lt"/>
+              </a:rPr>
               <a:t> questions </a:t>
             </a:r>
           </a:p>
@@ -14442,10 +13316,10 @@
       </p:sp>
       <p:sp>
         <p:nvSpPr>
-          <p:cNvPr id="24" name="Content Placeholder 2">
+          <p:cNvPr id="6" name="Content Placeholder 5">
             <a:extLst>
               <a:ext uri="{FF2B5EF4-FFF2-40B4-BE49-F238E27FC236}">
-                <a16:creationId xmlns:a16="http://schemas.microsoft.com/office/drawing/2014/main" id="{D7FDF29B-A281-F3CF-760D-321759BA8581}"/>
+                <a16:creationId xmlns:a16="http://schemas.microsoft.com/office/drawing/2014/main" id="{B41B92A7-C4DD-19B5-4CEE-1DEFC7F961BB}"/>
               </a:ext>
             </a:extLst>
           </p:cNvPr>
@@ -14453,18 +13327,18 @@
             <a:spLocks noGrp="1"/>
           </p:cNvSpPr>
           <p:nvPr>
-            <p:ph idx="1"/>
+            <p:ph sz="half" idx="2"/>
           </p:nvPr>
         </p:nvSpPr>
         <p:spPr>
           <a:xfrm>
-            <a:off x="6095999" y="713313"/>
-            <a:ext cx="5257801" cy="5431376"/>
+            <a:off x="5980176" y="866202"/>
+            <a:ext cx="5181600" cy="5305997"/>
           </a:xfrm>
         </p:spPr>
         <p:txBody>
-          <a:bodyPr anchor="ctr">
-            <a:normAutofit/>
+          <a:bodyPr>
+            <a:normAutofit lnSpcReduction="10000"/>
           </a:bodyPr>
           <a:lstStyle/>
           <a:p>
@@ -14472,71 +13346,79 @@
               <a:buNone/>
             </a:pPr>
             <a:r>
-              <a:rPr lang="fr-CH" sz="3200" dirty="0"/>
-              <a:t>1. </a:t>
-            </a:r>
-            <a:r>
-              <a:rPr lang="fr-CH" sz="3200" dirty="0" err="1"/>
+              <a:rPr lang="fr-CH" sz="3500" dirty="0">
+                <a:solidFill>
+                  <a:srgbClr val="98B2CB"/>
+                </a:solidFill>
+              </a:rPr>
+              <a:t>1.</a:t>
+            </a:r>
+            <a:r>
+              <a:rPr lang="fr-CH" sz="3500" dirty="0"/>
+              <a:t> </a:t>
+            </a:r>
+            <a:r>
+              <a:rPr lang="fr-CH" sz="3500" dirty="0" err="1"/>
               <a:t>What</a:t>
             </a:r>
             <a:r>
-              <a:rPr lang="fr-CH" sz="3200" dirty="0"/>
+              <a:rPr lang="fr-CH" sz="3500" dirty="0"/>
               <a:t> </a:t>
             </a:r>
             <a:r>
-              <a:rPr lang="fr-CH" sz="3200" dirty="0" err="1"/>
+              <a:rPr lang="fr-CH" sz="3500" dirty="0" err="1"/>
               <a:t>share</a:t>
             </a:r>
             <a:r>
-              <a:rPr lang="fr-CH" sz="3200" dirty="0"/>
+              <a:rPr lang="fr-CH" sz="3500" dirty="0"/>
               <a:t> of </a:t>
             </a:r>
             <a:r>
-              <a:rPr lang="fr-CH" sz="3200" dirty="0" err="1"/>
+              <a:rPr lang="fr-CH" sz="3500" dirty="0" err="1"/>
               <a:t>daily</a:t>
             </a:r>
             <a:r>
-              <a:rPr lang="fr-CH" sz="3200" dirty="0"/>
+              <a:rPr lang="fr-CH" sz="3500" dirty="0"/>
               <a:t> </a:t>
             </a:r>
             <a:r>
-              <a:rPr lang="fr-CH" sz="3200" dirty="0" err="1"/>
+              <a:rPr lang="fr-CH" sz="3500" dirty="0" err="1"/>
               <a:t>activities</a:t>
             </a:r>
             <a:r>
-              <a:rPr lang="fr-CH" sz="3200" dirty="0"/>
+              <a:rPr lang="fr-CH" sz="3500" dirty="0"/>
               <a:t> </a:t>
             </a:r>
             <a:r>
-              <a:rPr lang="fr-CH" sz="3200" dirty="0" err="1"/>
+              <a:rPr lang="fr-CH" sz="3500" dirty="0" err="1"/>
               <a:t>occurs</a:t>
             </a:r>
             <a:r>
-              <a:rPr lang="fr-CH" sz="3200" dirty="0"/>
+              <a:rPr lang="fr-CH" sz="3500" dirty="0"/>
               <a:t> </a:t>
             </a:r>
             <a:r>
-              <a:rPr lang="fr-CH" sz="3200" dirty="0" err="1"/>
+              <a:rPr lang="fr-CH" sz="3500" dirty="0" err="1"/>
               <a:t>within</a:t>
             </a:r>
             <a:r>
-              <a:rPr lang="fr-CH" sz="3200" dirty="0"/>
+              <a:rPr lang="fr-CH" sz="3500" dirty="0"/>
               <a:t> 15 minutes </a:t>
             </a:r>
             <a:r>
-              <a:rPr lang="fr-CH" sz="3200" dirty="0" err="1"/>
+              <a:rPr lang="fr-CH" sz="3500" dirty="0" err="1"/>
               <a:t>from</a:t>
             </a:r>
             <a:r>
-              <a:rPr lang="fr-CH" sz="3200" dirty="0"/>
+              <a:rPr lang="fr-CH" sz="3500" dirty="0"/>
               <a:t> home ? (per </a:t>
             </a:r>
             <a:r>
-              <a:rPr lang="fr-CH" sz="3200" dirty="0" err="1"/>
+              <a:rPr lang="fr-CH" sz="3500" dirty="0" err="1"/>
               <a:t>means</a:t>
             </a:r>
             <a:r>
-              <a:rPr lang="fr-CH" sz="3200" dirty="0"/>
+              <a:rPr lang="fr-CH" sz="3500" dirty="0"/>
               <a:t> of transportation)</a:t>
             </a:r>
           </a:p>
@@ -14545,63 +13427,71 @@
               <a:buNone/>
             </a:pPr>
             <a:r>
-              <a:rPr lang="fr-CH" sz="3200" dirty="0"/>
-              <a:t>2. How </a:t>
-            </a:r>
-            <a:r>
-              <a:rPr lang="fr-CH" sz="3200" dirty="0" err="1"/>
+              <a:rPr lang="fr-CH" sz="3500" dirty="0">
+                <a:solidFill>
+                  <a:srgbClr val="98B2CB"/>
+                </a:solidFill>
+              </a:rPr>
+              <a:t>2.</a:t>
+            </a:r>
+            <a:r>
+              <a:rPr lang="fr-CH" sz="3500" dirty="0"/>
+              <a:t> How </a:t>
+            </a:r>
+            <a:r>
+              <a:rPr lang="fr-CH" sz="3500" dirty="0" err="1"/>
               <a:t>does</a:t>
             </a:r>
             <a:r>
-              <a:rPr lang="fr-CH" sz="3200" dirty="0"/>
+              <a:rPr lang="fr-CH" sz="3500" dirty="0"/>
               <a:t> </a:t>
             </a:r>
             <a:r>
-              <a:rPr lang="fr-CH" sz="3200" dirty="0" err="1"/>
+              <a:rPr lang="fr-CH" sz="3500" dirty="0" err="1"/>
               <a:t>actual</a:t>
             </a:r>
             <a:r>
-              <a:rPr lang="fr-CH" sz="3200" dirty="0"/>
+              <a:rPr lang="fr-CH" sz="3500" dirty="0"/>
               <a:t> </a:t>
             </a:r>
             <a:r>
-              <a:rPr lang="fr-CH" sz="3200" dirty="0" err="1"/>
+              <a:rPr lang="fr-CH" sz="3500" dirty="0" err="1"/>
               <a:t>mobility</a:t>
             </a:r>
             <a:r>
-              <a:rPr lang="fr-CH" sz="3200" dirty="0"/>
+              <a:rPr lang="fr-CH" sz="3500" dirty="0"/>
               <a:t> </a:t>
             </a:r>
             <a:r>
-              <a:rPr lang="fr-CH" sz="3200" dirty="0" err="1"/>
+              <a:rPr lang="fr-CH" sz="3500" dirty="0" err="1"/>
               <a:t>differ</a:t>
             </a:r>
             <a:r>
-              <a:rPr lang="fr-CH" sz="3200" dirty="0"/>
+              <a:rPr lang="fr-CH" sz="3500" dirty="0"/>
               <a:t> </a:t>
             </a:r>
             <a:r>
-              <a:rPr lang="fr-CH" sz="3200" dirty="0" err="1"/>
+              <a:rPr lang="fr-CH" sz="3500" dirty="0" err="1"/>
               <a:t>from</a:t>
             </a:r>
             <a:r>
-              <a:rPr lang="fr-CH" sz="3200" dirty="0"/>
+              <a:rPr lang="fr-CH" sz="3500" dirty="0"/>
               <a:t> the </a:t>
             </a:r>
             <a:r>
-              <a:rPr lang="fr-CH" sz="3200" dirty="0" err="1"/>
+              <a:rPr lang="fr-CH" sz="3500" dirty="0" err="1"/>
               <a:t>theoretical</a:t>
             </a:r>
             <a:r>
-              <a:rPr lang="fr-CH" sz="3200" dirty="0"/>
+              <a:rPr lang="fr-CH" sz="3500" dirty="0"/>
               <a:t> </a:t>
             </a:r>
             <a:r>
-              <a:rPr lang="fr-CH" sz="3200" dirty="0" err="1"/>
+              <a:rPr lang="fr-CH" sz="3500" dirty="0" err="1"/>
               <a:t>accessibility</a:t>
             </a:r>
             <a:r>
-              <a:rPr lang="fr-CH" sz="3200" dirty="0"/>
+              <a:rPr lang="fr-CH" sz="3500" dirty="0"/>
               <a:t>? </a:t>
             </a:r>
           </a:p>
@@ -14610,64 +13500,75 @@
               <a:buNone/>
             </a:pPr>
             <a:r>
-              <a:rPr lang="fr-CH" sz="3200" dirty="0"/>
-              <a:t>3. </a:t>
-            </a:r>
-            <a:r>
-              <a:rPr lang="fr-CH" sz="3200" dirty="0" err="1"/>
+              <a:rPr lang="fr-CH" sz="3500" dirty="0">
+                <a:solidFill>
+                  <a:srgbClr val="98B2CB"/>
+                </a:solidFill>
+              </a:rPr>
+              <a:t>3.</a:t>
+            </a:r>
+            <a:r>
+              <a:rPr lang="fr-CH" sz="3500" dirty="0"/>
+              <a:t> </a:t>
+            </a:r>
+            <a:r>
+              <a:rPr lang="fr-CH" sz="3500" dirty="0" err="1"/>
               <a:t>Which</a:t>
             </a:r>
             <a:r>
-              <a:rPr lang="fr-CH" sz="3200" dirty="0"/>
+              <a:rPr lang="fr-CH" sz="3500" dirty="0"/>
               <a:t> types of </a:t>
             </a:r>
             <a:r>
-              <a:rPr lang="fr-CH" sz="3200" dirty="0" err="1"/>
+              <a:rPr lang="fr-CH" sz="3500" dirty="0" err="1"/>
               <a:t>activities</a:t>
             </a:r>
             <a:r>
-              <a:rPr lang="fr-CH" sz="3200" dirty="0"/>
+              <a:rPr lang="fr-CH" sz="3500" dirty="0"/>
               <a:t> </a:t>
             </a:r>
             <a:r>
-              <a:rPr lang="fr-CH" sz="3200" dirty="0" err="1"/>
+              <a:rPr lang="fr-CH" sz="3500" dirty="0" err="1"/>
               <a:t>most</a:t>
             </a:r>
             <a:r>
-              <a:rPr lang="fr-CH" sz="3200" dirty="0"/>
+              <a:rPr lang="fr-CH" sz="3500" dirty="0"/>
               <a:t> </a:t>
             </a:r>
             <a:r>
-              <a:rPr lang="fr-CH" sz="3200" dirty="0" err="1"/>
+              <a:rPr lang="fr-CH" sz="3500" dirty="0" err="1"/>
               <a:t>often</a:t>
             </a:r>
             <a:r>
-              <a:rPr lang="fr-CH" sz="3200" dirty="0"/>
+              <a:rPr lang="fr-CH" sz="3500" dirty="0"/>
               <a:t> </a:t>
             </a:r>
             <a:r>
-              <a:rPr lang="fr-CH" sz="3200" dirty="0" err="1"/>
+              <a:rPr lang="fr-CH" sz="3500" dirty="0" err="1"/>
               <a:t>occur</a:t>
             </a:r>
             <a:r>
-              <a:rPr lang="fr-CH" sz="3200" dirty="0"/>
+              <a:rPr lang="fr-CH" sz="3500" dirty="0"/>
               <a:t> </a:t>
             </a:r>
             <a:r>
-              <a:rPr lang="fr-CH" sz="3200" dirty="0" err="1"/>
+              <a:rPr lang="fr-CH" sz="3500" dirty="0" err="1"/>
               <a:t>beyond</a:t>
             </a:r>
             <a:r>
-              <a:rPr lang="fr-CH" sz="3200" dirty="0"/>
+              <a:rPr lang="fr-CH" sz="3500" dirty="0"/>
               <a:t> a 15‑minute radius?</a:t>
             </a:r>
+          </a:p>
+          <a:p>
+            <a:endParaRPr lang="fr-CH" dirty="0"/>
           </a:p>
         </p:txBody>
       </p:sp>
     </p:spTree>
     <p:extLst>
       <p:ext uri="{BB962C8B-B14F-4D97-AF65-F5344CB8AC3E}">
-        <p14:creationId xmlns:p14="http://schemas.microsoft.com/office/powerpoint/2010/main" val="3809305011"/>
+        <p14:creationId xmlns:p14="http://schemas.microsoft.com/office/powerpoint/2010/main" val="2745853101"/>
       </p:ext>
     </p:extLst>
   </p:cSld>
@@ -14677,212 +13578,7 @@
 </p:sld>
 </file>
 
-<file path=ppt/slides/slide6.xml><?xml version="1.0" encoding="utf-8"?>
-<p:sld xmlns:a="http://schemas.openxmlformats.org/drawingml/2006/main" xmlns:r="http://schemas.openxmlformats.org/officeDocument/2006/relationships" xmlns:p="http://schemas.openxmlformats.org/presentationml/2006/main">
-  <p:cSld>
-    <p:spTree>
-      <p:nvGrpSpPr>
-        <p:cNvPr id="1" name="">
-          <a:extLst>
-            <a:ext uri="{FF2B5EF4-FFF2-40B4-BE49-F238E27FC236}">
-              <a16:creationId xmlns:a16="http://schemas.microsoft.com/office/drawing/2014/main" id="{3D423E1E-BDBE-7890-99F7-75EB4E2501C1}"/>
-            </a:ext>
-          </a:extLst>
-        </p:cNvPr>
-        <p:cNvGrpSpPr/>
-        <p:nvPr/>
-      </p:nvGrpSpPr>
-      <p:grpSpPr>
-        <a:xfrm>
-          <a:off x="0" y="0"/>
-          <a:ext cx="0" cy="0"/>
-          <a:chOff x="0" y="0"/>
-          <a:chExt cx="0" cy="0"/>
-        </a:xfrm>
-      </p:grpSpPr>
-      <p:sp>
-        <p:nvSpPr>
-          <p:cNvPr id="2" name="Title 1">
-            <a:extLst>
-              <a:ext uri="{FF2B5EF4-FFF2-40B4-BE49-F238E27FC236}">
-                <a16:creationId xmlns:a16="http://schemas.microsoft.com/office/drawing/2014/main" id="{F68A396A-E78B-8B83-BCD1-2000A3ACC94E}"/>
-              </a:ext>
-            </a:extLst>
-          </p:cNvPr>
-          <p:cNvSpPr>
-            <a:spLocks noGrp="1"/>
-          </p:cNvSpPr>
-          <p:nvPr>
-            <p:ph type="title"/>
-          </p:nvPr>
-        </p:nvSpPr>
-        <p:spPr>
-          <a:xfrm>
-            <a:off x="838200" y="713312"/>
-            <a:ext cx="4038600" cy="3472607"/>
-          </a:xfrm>
-        </p:spPr>
-        <p:txBody>
-          <a:bodyPr>
-            <a:normAutofit/>
-          </a:bodyPr>
-          <a:lstStyle/>
-          <a:p>
-            <a:r>
-              <a:rPr lang="en-001" dirty="0"/>
-              <a:t>Best Possible Outcome</a:t>
-            </a:r>
-          </a:p>
-        </p:txBody>
-      </p:sp>
-      <p:sp>
-        <p:nvSpPr>
-          <p:cNvPr id="24" name="Content Placeholder 2">
-            <a:extLst>
-              <a:ext uri="{FF2B5EF4-FFF2-40B4-BE49-F238E27FC236}">
-                <a16:creationId xmlns:a16="http://schemas.microsoft.com/office/drawing/2014/main" id="{220A022F-93D1-8C5A-87A5-E8C8242FA292}"/>
-              </a:ext>
-            </a:extLst>
-          </p:cNvPr>
-          <p:cNvSpPr>
-            <a:spLocks noGrp="1"/>
-          </p:cNvSpPr>
-          <p:nvPr>
-            <p:ph idx="1"/>
-          </p:nvPr>
-        </p:nvSpPr>
-        <p:spPr>
-          <a:xfrm>
-            <a:off x="4876801" y="713313"/>
-            <a:ext cx="6477000" cy="3472607"/>
-          </a:xfrm>
-        </p:spPr>
-        <p:txBody>
-          <a:bodyPr anchor="ctr">
-            <a:normAutofit fontScale="92500" lnSpcReduction="10000"/>
-          </a:bodyPr>
-          <a:lstStyle/>
-          <a:p>
-            <a:pPr marL="0" indent="0">
-              <a:buNone/>
-            </a:pPr>
-            <a:r>
-              <a:rPr lang="en-001" sz="3200" dirty="0"/>
-              <a:t>We expect to:</a:t>
-            </a:r>
-          </a:p>
-          <a:p>
-            <a:r>
-              <a:rPr lang="en-001" sz="3200" dirty="0"/>
-              <a:t>Quantify the proportion of local vs non-local activities </a:t>
-            </a:r>
-          </a:p>
-          <a:p>
-            <a:r>
-              <a:rPr lang="en-001" sz="3200" dirty="0"/>
-              <a:t>Identify activity types that exceed the 15-minute threshold </a:t>
-            </a:r>
-          </a:p>
-          <a:p>
-            <a:r>
-              <a:rPr lang="en-001" sz="3200" dirty="0"/>
-              <a:t>Evaluate whether mobility is driven more by accessibility or by personal preferences and habits</a:t>
-            </a:r>
-          </a:p>
-        </p:txBody>
-      </p:sp>
-      <p:sp>
-        <p:nvSpPr>
-          <p:cNvPr id="3" name="Rectangle 2">
-            <a:extLst>
-              <a:ext uri="{FF2B5EF4-FFF2-40B4-BE49-F238E27FC236}">
-                <a16:creationId xmlns:a16="http://schemas.microsoft.com/office/drawing/2014/main" id="{7054B78A-D08B-EF49-5DCE-3E78CEFBEEF3}"/>
-              </a:ext>
-            </a:extLst>
-          </p:cNvPr>
-          <p:cNvSpPr/>
-          <p:nvPr/>
-        </p:nvSpPr>
-        <p:spPr>
-          <a:xfrm>
-            <a:off x="0" y="4795520"/>
-            <a:ext cx="12192000" cy="1561737"/>
-          </a:xfrm>
-          <a:prstGeom prst="rect">
-            <a:avLst/>
-          </a:prstGeom>
-          <a:solidFill>
-            <a:srgbClr val="F4F4F4"/>
-          </a:solidFill>
-          <a:ln>
-            <a:noFill/>
-          </a:ln>
-        </p:spPr>
-        <p:style>
-          <a:lnRef idx="2">
-            <a:schemeClr val="accent1">
-              <a:shade val="15000"/>
-            </a:schemeClr>
-          </a:lnRef>
-          <a:fillRef idx="1">
-            <a:schemeClr val="accent1"/>
-          </a:fillRef>
-          <a:effectRef idx="0">
-            <a:schemeClr val="accent1"/>
-          </a:effectRef>
-          <a:fontRef idx="minor">
-            <a:schemeClr val="lt1"/>
-          </a:fontRef>
-        </p:style>
-        <p:txBody>
-          <a:bodyPr rtlCol="0" anchor="ctr"/>
-          <a:lstStyle/>
-          <a:p>
-            <a:pPr algn="ctr"/>
-            <a:r>
-              <a:rPr lang="en-001" sz="2200" b="1" dirty="0">
-                <a:solidFill>
-                  <a:schemeClr val="tx1"/>
-                </a:solidFill>
-              </a:rPr>
-              <a:t>Hypothesis:</a:t>
-            </a:r>
-            <a:r>
-              <a:rPr lang="en-001" sz="2200" dirty="0">
-                <a:solidFill>
-                  <a:schemeClr val="tx1"/>
-                </a:solidFill>
-              </a:rPr>
-              <a:t> Even in Zurich, many social and professional activities </a:t>
-            </a:r>
-          </a:p>
-          <a:p>
-            <a:pPr algn="ctr"/>
-            <a:r>
-              <a:rPr lang="en-001" sz="2200" dirty="0">
-                <a:solidFill>
-                  <a:schemeClr val="tx1"/>
-                </a:solidFill>
-              </a:rPr>
-              <a:t>occur beyond the theoretically accessible area</a:t>
-            </a:r>
-          </a:p>
-        </p:txBody>
-      </p:sp>
-    </p:spTree>
-    <p:extLst>
-      <p:ext uri="{BB962C8B-B14F-4D97-AF65-F5344CB8AC3E}">
-        <p14:creationId xmlns:p14="http://schemas.microsoft.com/office/powerpoint/2010/main" val="2129016569"/>
-      </p:ext>
-    </p:extLst>
-  </p:cSld>
-  <p:clrMapOvr>
-    <a:masterClrMapping/>
-  </p:clrMapOvr>
-</p:sld>
-</file>
-
-<file path=ppt/slides/slide7.xml><?xml version="1.0" encoding="utf-8"?>
+<file path=ppt/slides/slide4.xml><?xml version="1.0" encoding="utf-8"?>
 <p:sld xmlns:a="http://schemas.openxmlformats.org/drawingml/2006/main" xmlns:r="http://schemas.openxmlformats.org/officeDocument/2006/relationships" xmlns:p="http://schemas.openxmlformats.org/presentationml/2006/main">
   <p:cSld>
     <p:spTree>
@@ -15227,7 +13923,7 @@
 </p:sld>
 </file>
 
-<file path=ppt/slides/slide8.xml><?xml version="1.0" encoding="utf-8"?>
+<file path=ppt/slides/slide5.xml><?xml version="1.0" encoding="utf-8"?>
 <p:sld xmlns:a="http://schemas.openxmlformats.org/drawingml/2006/main" xmlns:r="http://schemas.openxmlformats.org/officeDocument/2006/relationships" xmlns:p="http://schemas.openxmlformats.org/presentationml/2006/main">
   <p:cSld>
     <p:bg>
@@ -17994,7 +16690,7 @@
 </p:sld>
 </file>
 
-<file path=ppt/slides/slide9.xml><?xml version="1.0" encoding="utf-8"?>
+<file path=ppt/slides/slide6.xml><?xml version="1.0" encoding="utf-8"?>
 <p:sld xmlns:a="http://schemas.openxmlformats.org/drawingml/2006/main" xmlns:r="http://schemas.openxmlformats.org/officeDocument/2006/relationships" xmlns:p="http://schemas.openxmlformats.org/presentationml/2006/main">
   <p:cSld>
     <p:spTree>
@@ -18087,6 +16783,544 @@
     <p:extLst>
       <p:ext uri="{BB962C8B-B14F-4D97-AF65-F5344CB8AC3E}">
         <p14:creationId xmlns:p14="http://schemas.microsoft.com/office/powerpoint/2010/main" val="1701537491"/>
+      </p:ext>
+    </p:extLst>
+  </p:cSld>
+  <p:clrMapOvr>
+    <a:masterClrMapping/>
+  </p:clrMapOvr>
+</p:sld>
+</file>
+
+<file path=ppt/slides/slide7.xml><?xml version="1.0" encoding="utf-8"?>
+<p:sld xmlns:a="http://schemas.openxmlformats.org/drawingml/2006/main" xmlns:r="http://schemas.openxmlformats.org/officeDocument/2006/relationships" xmlns:p="http://schemas.openxmlformats.org/presentationml/2006/main">
+  <p:cSld>
+    <p:spTree>
+      <p:nvGrpSpPr>
+        <p:cNvPr id="1" name=""/>
+        <p:cNvGrpSpPr/>
+        <p:nvPr/>
+      </p:nvGrpSpPr>
+      <p:grpSpPr>
+        <a:xfrm>
+          <a:off x="0" y="0"/>
+          <a:ext cx="0" cy="0"/>
+          <a:chOff x="0" y="0"/>
+          <a:chExt cx="0" cy="0"/>
+        </a:xfrm>
+      </p:grpSpPr>
+      <p:sp>
+        <p:nvSpPr>
+          <p:cNvPr id="2" name="Title 1">
+            <a:extLst>
+              <a:ext uri="{FF2B5EF4-FFF2-40B4-BE49-F238E27FC236}">
+                <a16:creationId xmlns:a16="http://schemas.microsoft.com/office/drawing/2014/main" id="{8B6FD0A6-936D-1217-2307-54883D928515}"/>
+              </a:ext>
+            </a:extLst>
+          </p:cNvPr>
+          <p:cNvSpPr>
+            <a:spLocks noGrp="1"/>
+          </p:cNvSpPr>
+          <p:nvPr>
+            <p:ph type="title"/>
+          </p:nvPr>
+        </p:nvSpPr>
+        <p:spPr/>
+        <p:txBody>
+          <a:bodyPr>
+            <a:normAutofit/>
+          </a:bodyPr>
+          <a:lstStyle/>
+          <a:p>
+            <a:r>
+              <a:rPr lang="en-001" sz="4000" dirty="0"/>
+              <a:t>Activities occurring beyond the 15-minute city</a:t>
+            </a:r>
+          </a:p>
+        </p:txBody>
+      </p:sp>
+      <p:pic>
+        <p:nvPicPr>
+          <p:cNvPr id="5" name="Content Placeholder 4">
+            <a:extLst>
+              <a:ext uri="{FF2B5EF4-FFF2-40B4-BE49-F238E27FC236}">
+                <a16:creationId xmlns:a16="http://schemas.microsoft.com/office/drawing/2014/main" id="{0A24CC37-D9A8-59DF-A14B-5BF03F157956}"/>
+              </a:ext>
+            </a:extLst>
+          </p:cNvPr>
+          <p:cNvPicPr>
+            <a:picLocks noGrp="1" noChangeAspect="1"/>
+          </p:cNvPicPr>
+          <p:nvPr>
+            <p:ph idx="1"/>
+          </p:nvPr>
+        </p:nvPicPr>
+        <p:blipFill>
+          <a:blip r:embed="rId2">
+            <a:extLst>
+              <a:ext uri="{28A0092B-C50C-407E-A947-70E740481C1C}">
+                <a14:useLocalDpi xmlns:a14="http://schemas.microsoft.com/office/drawing/2010/main" val="0"/>
+              </a:ext>
+            </a:extLst>
+          </a:blip>
+          <a:srcRect t="11781"/>
+          <a:stretch>
+            <a:fillRect/>
+          </a:stretch>
+        </p:blipFill>
+        <p:spPr>
+          <a:xfrm>
+            <a:off x="1431183" y="1470991"/>
+            <a:ext cx="8726608" cy="5281533"/>
+          </a:xfrm>
+          <a:prstGeom prst="rect">
+            <a:avLst/>
+          </a:prstGeom>
+        </p:spPr>
+      </p:pic>
+    </p:spTree>
+    <p:extLst>
+      <p:ext uri="{BB962C8B-B14F-4D97-AF65-F5344CB8AC3E}">
+        <p14:creationId xmlns:p14="http://schemas.microsoft.com/office/powerpoint/2010/main" val="3855054443"/>
+      </p:ext>
+    </p:extLst>
+  </p:cSld>
+  <p:clrMapOvr>
+    <a:masterClrMapping/>
+  </p:clrMapOvr>
+</p:sld>
+</file>
+
+<file path=ppt/slides/slide8.xml><?xml version="1.0" encoding="utf-8"?>
+<p:sld xmlns:a="http://schemas.openxmlformats.org/drawingml/2006/main" xmlns:r="http://schemas.openxmlformats.org/officeDocument/2006/relationships" xmlns:p="http://schemas.openxmlformats.org/presentationml/2006/main">
+  <p:cSld>
+    <p:spTree>
+      <p:nvGrpSpPr>
+        <p:cNvPr id="1" name=""/>
+        <p:cNvGrpSpPr/>
+        <p:nvPr/>
+      </p:nvGrpSpPr>
+      <p:grpSpPr>
+        <a:xfrm>
+          <a:off x="0" y="0"/>
+          <a:ext cx="0" cy="0"/>
+          <a:chOff x="0" y="0"/>
+          <a:chExt cx="0" cy="0"/>
+        </a:xfrm>
+      </p:grpSpPr>
+      <p:sp>
+        <p:nvSpPr>
+          <p:cNvPr id="2" name="Title 1">
+            <a:extLst>
+              <a:ext uri="{FF2B5EF4-FFF2-40B4-BE49-F238E27FC236}">
+                <a16:creationId xmlns:a16="http://schemas.microsoft.com/office/drawing/2014/main" id="{64BD1728-17B5-5125-78E7-BBA36653063B}"/>
+              </a:ext>
+            </a:extLst>
+          </p:cNvPr>
+          <p:cNvSpPr>
+            <a:spLocks noGrp="1"/>
+          </p:cNvSpPr>
+          <p:nvPr>
+            <p:ph type="title"/>
+          </p:nvPr>
+        </p:nvSpPr>
+        <p:spPr/>
+        <p:txBody>
+          <a:bodyPr/>
+          <a:lstStyle/>
+          <a:p>
+            <a:endParaRPr lang="fr-CH"/>
+          </a:p>
+        </p:txBody>
+      </p:sp>
+      <p:sp>
+        <p:nvSpPr>
+          <p:cNvPr id="7" name="Content Placeholder 6">
+            <a:extLst>
+              <a:ext uri="{FF2B5EF4-FFF2-40B4-BE49-F238E27FC236}">
+                <a16:creationId xmlns:a16="http://schemas.microsoft.com/office/drawing/2014/main" id="{DCCFBE5E-470E-8AAF-8F23-FDD7777AA6DC}"/>
+              </a:ext>
+            </a:extLst>
+          </p:cNvPr>
+          <p:cNvSpPr>
+            <a:spLocks noGrp="1"/>
+          </p:cNvSpPr>
+          <p:nvPr>
+            <p:ph idx="1"/>
+          </p:nvPr>
+        </p:nvSpPr>
+        <p:spPr/>
+        <p:txBody>
+          <a:bodyPr/>
+          <a:lstStyle/>
+          <a:p>
+            <a:endParaRPr lang="fr-CH"/>
+          </a:p>
+        </p:txBody>
+      </p:sp>
+      <p:pic>
+        <p:nvPicPr>
+          <p:cNvPr id="9" name="Picture 8" descr="The image displays a map overlaying various locations in ZURICH, indicating distances for different modes of transportation (walking, cycling, and public transport) from a central point.&#10;&#10;AI-generated content may be incorrect.">
+            <a:extLst>
+              <a:ext uri="{FF2B5EF4-FFF2-40B4-BE49-F238E27FC236}">
+                <a16:creationId xmlns:a16="http://schemas.microsoft.com/office/drawing/2014/main" id="{2CAB6DAC-E835-6F5C-E5D4-339A9645C7BE}"/>
+              </a:ext>
+            </a:extLst>
+          </p:cNvPr>
+          <p:cNvPicPr>
+            <a:picLocks noChangeAspect="1"/>
+          </p:cNvPicPr>
+          <p:nvPr/>
+        </p:nvPicPr>
+        <p:blipFill>
+          <a:blip r:embed="rId2"/>
+          <a:stretch>
+            <a:fillRect/>
+          </a:stretch>
+        </p:blipFill>
+        <p:spPr>
+          <a:xfrm>
+            <a:off x="198120" y="0"/>
+            <a:ext cx="11795760" cy="6858000"/>
+          </a:xfrm>
+          <a:prstGeom prst="rect">
+            <a:avLst/>
+          </a:prstGeom>
+        </p:spPr>
+      </p:pic>
+    </p:spTree>
+    <p:extLst>
+      <p:ext uri="{BB962C8B-B14F-4D97-AF65-F5344CB8AC3E}">
+        <p14:creationId xmlns:p14="http://schemas.microsoft.com/office/powerpoint/2010/main" val="2036194352"/>
+      </p:ext>
+    </p:extLst>
+  </p:cSld>
+  <p:clrMapOvr>
+    <a:masterClrMapping/>
+  </p:clrMapOvr>
+</p:sld>
+</file>
+
+<file path=ppt/slides/slide9.xml><?xml version="1.0" encoding="utf-8"?>
+<p:sld xmlns:a="http://schemas.openxmlformats.org/drawingml/2006/main" xmlns:r="http://schemas.openxmlformats.org/officeDocument/2006/relationships" xmlns:p="http://schemas.openxmlformats.org/presentationml/2006/main">
+  <p:cSld>
+    <p:spTree>
+      <p:nvGrpSpPr>
+        <p:cNvPr id="1" name=""/>
+        <p:cNvGrpSpPr/>
+        <p:nvPr/>
+      </p:nvGrpSpPr>
+      <p:grpSpPr>
+        <a:xfrm>
+          <a:off x="0" y="0"/>
+          <a:ext cx="0" cy="0"/>
+          <a:chOff x="0" y="0"/>
+          <a:chExt cx="0" cy="0"/>
+        </a:xfrm>
+      </p:grpSpPr>
+      <p:sp>
+        <p:nvSpPr>
+          <p:cNvPr id="2" name="Title 1">
+            <a:extLst>
+              <a:ext uri="{FF2B5EF4-FFF2-40B4-BE49-F238E27FC236}">
+                <a16:creationId xmlns:a16="http://schemas.microsoft.com/office/drawing/2014/main" id="{229A9C5E-D113-F410-1D52-CFEDFDD68709}"/>
+              </a:ext>
+            </a:extLst>
+          </p:cNvPr>
+          <p:cNvSpPr>
+            <a:spLocks noGrp="1"/>
+          </p:cNvSpPr>
+          <p:nvPr>
+            <p:ph type="title"/>
+          </p:nvPr>
+        </p:nvSpPr>
+        <p:spPr/>
+        <p:txBody>
+          <a:bodyPr/>
+          <a:lstStyle/>
+          <a:p>
+            <a:r>
+              <a:rPr lang="fr-CH" dirty="0"/>
+              <a:t>Challenges and Plan B</a:t>
+            </a:r>
+          </a:p>
+        </p:txBody>
+      </p:sp>
+      <p:sp>
+        <p:nvSpPr>
+          <p:cNvPr id="3" name="Content Placeholder 2">
+            <a:extLst>
+              <a:ext uri="{FF2B5EF4-FFF2-40B4-BE49-F238E27FC236}">
+                <a16:creationId xmlns:a16="http://schemas.microsoft.com/office/drawing/2014/main" id="{DBAEEBF5-C3D9-FA63-1735-E9C2F5C42998}"/>
+              </a:ext>
+            </a:extLst>
+          </p:cNvPr>
+          <p:cNvSpPr>
+            <a:spLocks noGrp="1"/>
+          </p:cNvSpPr>
+          <p:nvPr>
+            <p:ph idx="1"/>
+          </p:nvPr>
+        </p:nvSpPr>
+        <p:spPr/>
+        <p:txBody>
+          <a:bodyPr/>
+          <a:lstStyle/>
+          <a:p>
+            <a:r>
+              <a:rPr lang="fr-CH" dirty="0" err="1"/>
+              <a:t>Integration</a:t>
+            </a:r>
+            <a:r>
+              <a:rPr lang="fr-CH" dirty="0"/>
+              <a:t> of the ZVV time plan </a:t>
+            </a:r>
+          </a:p>
+          <a:p>
+            <a:pPr lvl="1"/>
+            <a:r>
+              <a:rPr lang="fr-CH" dirty="0"/>
+              <a:t>Heavy data set </a:t>
+            </a:r>
+          </a:p>
+          <a:p>
+            <a:pPr lvl="1"/>
+            <a:r>
+              <a:rPr lang="fr-CH" dirty="0"/>
+              <a:t>Add </a:t>
+            </a:r>
+            <a:r>
+              <a:rPr lang="fr-CH" dirty="0" err="1"/>
+              <a:t>unusefull</a:t>
+            </a:r>
+            <a:r>
+              <a:rPr lang="fr-CH" dirty="0"/>
+              <a:t> complication</a:t>
+            </a:r>
+            <a:endParaRPr lang="fr-CH" dirty="0">
+              <a:sym typeface="Wingdings" panose="05000000000000000000" pitchFamily="2" charset="2"/>
+            </a:endParaRPr>
+          </a:p>
+          <a:p>
+            <a:pPr>
+              <a:buFont typeface="Wingdings" panose="05000000000000000000" pitchFamily="2" charset="2"/>
+              <a:buChar char="à"/>
+            </a:pPr>
+            <a:r>
+              <a:rPr lang="fr-CH" dirty="0">
+                <a:sym typeface="Wingdings" panose="05000000000000000000" pitchFamily="2" charset="2"/>
+              </a:rPr>
+              <a:t> Use an estimation of the speed of the public transports (bus and tram) of 15 km/h </a:t>
+            </a:r>
+          </a:p>
+          <a:p>
+            <a:r>
+              <a:rPr lang="fr-CH" dirty="0">
+                <a:sym typeface="Wingdings" panose="05000000000000000000" pitchFamily="2" charset="2"/>
+              </a:rPr>
+              <a:t>Anonymisation of the data</a:t>
+            </a:r>
+          </a:p>
+          <a:p>
+            <a:pPr lvl="1"/>
+            <a:r>
+              <a:rPr lang="fr-CH" dirty="0">
+                <a:sym typeface="Wingdings" panose="05000000000000000000" pitchFamily="2" charset="2"/>
+              </a:rPr>
+              <a:t>With </a:t>
+            </a:r>
+            <a:r>
+              <a:rPr lang="fr-CH" dirty="0" err="1">
+                <a:sym typeface="Wingdings" panose="05000000000000000000" pitchFamily="2" charset="2"/>
+              </a:rPr>
+              <a:t>only</a:t>
+            </a:r>
+            <a:r>
+              <a:rPr lang="fr-CH" dirty="0">
+                <a:sym typeface="Wingdings" panose="05000000000000000000" pitchFamily="2" charset="2"/>
+              </a:rPr>
+              <a:t> a few </a:t>
+            </a:r>
+            <a:r>
+              <a:rPr lang="fr-CH" dirty="0" err="1">
+                <a:sym typeface="Wingdings" panose="05000000000000000000" pitchFamily="2" charset="2"/>
+              </a:rPr>
+              <a:t>visited</a:t>
+            </a:r>
+            <a:r>
+              <a:rPr lang="fr-CH" dirty="0">
+                <a:sym typeface="Wingdings" panose="05000000000000000000" pitchFamily="2" charset="2"/>
+              </a:rPr>
+              <a:t> points, </a:t>
+            </a:r>
+            <a:r>
+              <a:rPr lang="fr-CH" dirty="0" err="1">
+                <a:sym typeface="Wingdings" panose="05000000000000000000" pitchFamily="2" charset="2"/>
+              </a:rPr>
+              <a:t>it</a:t>
+            </a:r>
+            <a:r>
+              <a:rPr lang="fr-CH" dirty="0">
+                <a:sym typeface="Wingdings" panose="05000000000000000000" pitchFamily="2" charset="2"/>
+              </a:rPr>
+              <a:t> </a:t>
+            </a:r>
+            <a:r>
+              <a:rPr lang="fr-CH" dirty="0" err="1">
+                <a:sym typeface="Wingdings" panose="05000000000000000000" pitchFamily="2" charset="2"/>
+              </a:rPr>
+              <a:t>is</a:t>
+            </a:r>
+            <a:r>
+              <a:rPr lang="fr-CH" dirty="0">
+                <a:sym typeface="Wingdings" panose="05000000000000000000" pitchFamily="2" charset="2"/>
+              </a:rPr>
+              <a:t> possible to </a:t>
+            </a:r>
+            <a:r>
+              <a:rPr lang="fr-CH" dirty="0" err="1">
+                <a:sym typeface="Wingdings" panose="05000000000000000000" pitchFamily="2" charset="2"/>
+              </a:rPr>
+              <a:t>find</a:t>
+            </a:r>
+            <a:r>
+              <a:rPr lang="fr-CH" dirty="0">
+                <a:sym typeface="Wingdings" panose="05000000000000000000" pitchFamily="2" charset="2"/>
+              </a:rPr>
+              <a:t> out </a:t>
+            </a:r>
+            <a:r>
+              <a:rPr lang="fr-CH" dirty="0" err="1">
+                <a:sym typeface="Wingdings" panose="05000000000000000000" pitchFamily="2" charset="2"/>
+              </a:rPr>
+              <a:t>where</a:t>
+            </a:r>
+            <a:r>
+              <a:rPr lang="fr-CH" dirty="0">
+                <a:sym typeface="Wingdings" panose="05000000000000000000" pitchFamily="2" charset="2"/>
+              </a:rPr>
+              <a:t> the </a:t>
+            </a:r>
+            <a:r>
+              <a:rPr lang="fr-CH" dirty="0" err="1">
+                <a:sym typeface="Wingdings" panose="05000000000000000000" pitchFamily="2" charset="2"/>
+              </a:rPr>
+              <a:t>person</a:t>
+            </a:r>
+            <a:r>
+              <a:rPr lang="fr-CH" dirty="0">
+                <a:sym typeface="Wingdings" panose="05000000000000000000" pitchFamily="2" charset="2"/>
+              </a:rPr>
+              <a:t> </a:t>
+            </a:r>
+            <a:r>
+              <a:rPr lang="fr-CH" dirty="0" err="1">
+                <a:sym typeface="Wingdings" panose="05000000000000000000" pitchFamily="2" charset="2"/>
+              </a:rPr>
+              <a:t>lives</a:t>
+            </a:r>
+            <a:r>
+              <a:rPr lang="fr-CH" dirty="0">
+                <a:sym typeface="Wingdings" panose="05000000000000000000" pitchFamily="2" charset="2"/>
+              </a:rPr>
+              <a:t>/</a:t>
+            </a:r>
+            <a:r>
+              <a:rPr lang="fr-CH" dirty="0" err="1">
+                <a:sym typeface="Wingdings" panose="05000000000000000000" pitchFamily="2" charset="2"/>
+              </a:rPr>
+              <a:t>who</a:t>
+            </a:r>
+            <a:r>
+              <a:rPr lang="fr-CH" dirty="0">
+                <a:sym typeface="Wingdings" panose="05000000000000000000" pitchFamily="2" charset="2"/>
+              </a:rPr>
+              <a:t> </a:t>
+            </a:r>
+            <a:r>
+              <a:rPr lang="fr-CH" dirty="0" err="1">
+                <a:sym typeface="Wingdings" panose="05000000000000000000" pitchFamily="2" charset="2"/>
+              </a:rPr>
+              <a:t>they</a:t>
+            </a:r>
+            <a:r>
+              <a:rPr lang="fr-CH" dirty="0">
+                <a:sym typeface="Wingdings" panose="05000000000000000000" pitchFamily="2" charset="2"/>
+              </a:rPr>
+              <a:t> are</a:t>
+            </a:r>
+          </a:p>
+          <a:p>
+            <a:pPr marL="0" indent="0">
+              <a:buNone/>
+            </a:pPr>
+            <a:r>
+              <a:rPr lang="fr-CH" dirty="0">
+                <a:sym typeface="Wingdings" panose="05000000000000000000" pitchFamily="2" charset="2"/>
+              </a:rPr>
+              <a:t> Change the </a:t>
+            </a:r>
+            <a:r>
+              <a:rPr lang="fr-CH" dirty="0" err="1">
+                <a:sym typeface="Wingdings" panose="05000000000000000000" pitchFamily="2" charset="2"/>
+              </a:rPr>
+              <a:t>adress</a:t>
+            </a:r>
+            <a:r>
+              <a:rPr lang="fr-CH" dirty="0">
+                <a:sym typeface="Wingdings" panose="05000000000000000000" pitchFamily="2" charset="2"/>
+              </a:rPr>
+              <a:t> by a few blocks/</a:t>
+            </a:r>
+            <a:r>
+              <a:rPr lang="fr-CH" dirty="0" err="1">
+                <a:sym typeface="Wingdings" panose="05000000000000000000" pitchFamily="2" charset="2"/>
+              </a:rPr>
+              <a:t>streets</a:t>
+            </a:r>
+            <a:r>
+              <a:rPr lang="fr-CH" dirty="0">
+                <a:sym typeface="Wingdings" panose="05000000000000000000" pitchFamily="2" charset="2"/>
+              </a:rPr>
+              <a:t> (but </a:t>
+            </a:r>
+            <a:r>
+              <a:rPr lang="fr-CH" dirty="0" err="1">
+                <a:sym typeface="Wingdings" panose="05000000000000000000" pitchFamily="2" charset="2"/>
+              </a:rPr>
+              <a:t>still</a:t>
+            </a:r>
+            <a:r>
+              <a:rPr lang="fr-CH" dirty="0">
+                <a:sym typeface="Wingdings" panose="05000000000000000000" pitchFamily="2" charset="2"/>
+              </a:rPr>
+              <a:t> not </a:t>
+            </a:r>
+            <a:r>
+              <a:rPr lang="fr-CH" dirty="0" err="1">
+                <a:sym typeface="Wingdings" panose="05000000000000000000" pitchFamily="2" charset="2"/>
+              </a:rPr>
+              <a:t>ideal</a:t>
+            </a:r>
+            <a:r>
+              <a:rPr lang="fr-CH" dirty="0">
+                <a:sym typeface="Wingdings" panose="05000000000000000000" pitchFamily="2" charset="2"/>
+              </a:rPr>
+              <a:t>) </a:t>
+            </a:r>
+          </a:p>
+          <a:p>
+            <a:pPr marL="0" indent="0">
+              <a:buNone/>
+            </a:pPr>
+            <a:endParaRPr lang="fr-CH" dirty="0"/>
+          </a:p>
+        </p:txBody>
+      </p:sp>
+    </p:spTree>
+    <p:extLst>
+      <p:ext uri="{BB962C8B-B14F-4D97-AF65-F5344CB8AC3E}">
+        <p14:creationId xmlns:p14="http://schemas.microsoft.com/office/powerpoint/2010/main" val="2357305363"/>
       </p:ext>
     </p:extLst>
   </p:cSld>

</xml_diff>